<commit_message>
Left align presentation body text
</commit_message>
<xml_diff>
--- a/docs/presentation/adaptive_evidence_acquisition_grounded_videoqa_presentation.pptx
+++ b/docs/presentation/adaptive_evidence_acquisition_grounded_videoqa_presentation.pptx
@@ -78,7 +78,7 @@
         <p:txBody>
           <a:bodyPr/>
           <a:p>
-            <a:fld id="{E43C3CF9-4663-47BE-B75A-B971A500FB28}" type="slidenum">
+            <a:fld id="{232F07CD-4478-4707-91F0-89801D5B9E74}" type="slidenum">
               <a:t>&lt;#&gt;</a:t>
             </a:fld>
           </a:p>
@@ -266,7 +266,7 @@
         <p:txBody>
           <a:bodyPr/>
           <a:p>
-            <a:fld id="{93D5CE7D-50D6-448C-8D56-FFD1AC286F9D}" type="slidenum">
+            <a:fld id="{A7B18FB2-3A6B-4A28-9197-AE841A8AB618}" type="slidenum">
               <a:t>&lt;#&gt;</a:t>
             </a:fld>
           </a:p>
@@ -522,7 +522,7 @@
         <p:txBody>
           <a:bodyPr/>
           <a:p>
-            <a:fld id="{CBF4CF02-3069-40F7-A431-43DEA600BE3E}" type="slidenum">
+            <a:fld id="{F88D5520-A277-4E9C-B8DE-BC6F118AF418}" type="slidenum">
               <a:t>&lt;#&gt;</a:t>
             </a:fld>
           </a:p>
@@ -846,7 +846,7 @@
         <p:txBody>
           <a:bodyPr/>
           <a:p>
-            <a:fld id="{2325DF1C-2792-4253-818C-1A4E622218C7}" type="slidenum">
+            <a:fld id="{623773FC-77B3-4200-9053-41710403E2C2}" type="slidenum">
               <a:t>&lt;#&gt;</a:t>
             </a:fld>
           </a:p>
@@ -1003,7 +1003,7 @@
         <p:txBody>
           <a:bodyPr/>
           <a:p>
-            <a:fld id="{9AF19517-6D8F-4B36-B340-833D59AAD2CB}" type="slidenum">
+            <a:fld id="{7205300D-8B22-446B-9A9D-3000D4EB48BD}" type="slidenum">
               <a:t>&lt;#&gt;</a:t>
             </a:fld>
           </a:p>
@@ -1157,7 +1157,7 @@
         <p:txBody>
           <a:bodyPr/>
           <a:p>
-            <a:fld id="{D4795399-37D8-4883-9347-496C0D16DD28}" type="slidenum">
+            <a:fld id="{C5051B86-7A06-499E-97A9-D2E43F02A827}" type="slidenum">
               <a:t>&lt;#&gt;</a:t>
             </a:fld>
           </a:p>
@@ -1345,7 +1345,7 @@
         <p:txBody>
           <a:bodyPr/>
           <a:p>
-            <a:fld id="{26101553-C9D5-42EE-B01B-6A5D2CBB35FC}" type="slidenum">
+            <a:fld id="{9557B0AF-848D-4AAB-9E04-D9B275F4AC94}" type="slidenum">
               <a:t>&lt;#&gt;</a:t>
             </a:fld>
           </a:p>
@@ -1465,7 +1465,7 @@
         <p:txBody>
           <a:bodyPr/>
           <a:p>
-            <a:fld id="{AF2281B6-E8C1-4ACC-A0C6-56A4C8F88862}" type="slidenum">
+            <a:fld id="{F3848838-E80F-490D-BFC1-3BE51C50CCF2}" type="slidenum">
               <a:t>&lt;#&gt;</a:t>
             </a:fld>
           </a:p>
@@ -1585,7 +1585,7 @@
         <p:txBody>
           <a:bodyPr/>
           <a:p>
-            <a:fld id="{C6147C86-BD08-425F-86CF-159934AD5F8B}" type="slidenum">
+            <a:fld id="{956CAFE0-4F62-413C-955B-5B5545A2313F}" type="slidenum">
               <a:t>&lt;#&gt;</a:t>
             </a:fld>
           </a:p>
@@ -1807,7 +1807,7 @@
         <p:txBody>
           <a:bodyPr/>
           <a:p>
-            <a:fld id="{FB2C5565-8322-413B-B4F5-DD5009DFD8B5}" type="slidenum">
+            <a:fld id="{DE87121A-6FC2-4999-A791-FE1BDF2A2089}" type="slidenum">
               <a:t>&lt;#&gt;</a:t>
             </a:fld>
           </a:p>
@@ -2029,7 +2029,7 @@
         <p:txBody>
           <a:bodyPr/>
           <a:p>
-            <a:fld id="{00A21807-E2DE-44FC-8C0A-A7D689980D48}" type="slidenum">
+            <a:fld id="{AA7A10D7-4237-41DE-B210-27430D23E8B4}" type="slidenum">
               <a:t>&lt;#&gt;</a:t>
             </a:fld>
           </a:p>
@@ -2251,7 +2251,7 @@
         <p:txBody>
           <a:bodyPr/>
           <a:p>
-            <a:fld id="{3C4CDA24-E7DC-4E9A-A490-9D35295BAF1B}" type="slidenum">
+            <a:fld id="{343E3F04-244F-438A-A499-FD723D996497}" type="slidenum">
               <a:t>&lt;#&gt;</a:t>
             </a:fld>
           </a:p>
@@ -2320,7 +2320,7 @@
         <p:spPr>
           <a:xfrm>
             <a:off x="3124080" y="6356520"/>
-            <a:ext cx="2893680" cy="363240"/>
+            <a:ext cx="2893320" cy="362880"/>
           </a:xfrm>
           <a:prstGeom prst="rect">
             <a:avLst/>
@@ -2377,7 +2377,7 @@
         <p:spPr>
           <a:xfrm>
             <a:off x="6553080" y="6356520"/>
-            <a:ext cx="2131920" cy="363240"/>
+            <a:ext cx="2131560" cy="362880"/>
           </a:xfrm>
           <a:prstGeom prst="rect">
             <a:avLst/>
@@ -2412,7 +2412,7 @@
               </a:lnSpc>
               <a:buNone/>
             </a:pPr>
-            <a:fld id="{37E30D77-CC9B-4A40-9F89-5F014F4FAFD7}" type="slidenum">
+            <a:fld id="{650E3BB0-5E18-4B42-9FD5-1D54E4AD478C}" type="slidenum">
               <a:rPr b="0" lang="en-US" sz="1200" spc="-1" strike="noStrike">
                 <a:solidFill>
                   <a:srgbClr val="8b8b8b"/>
@@ -2440,7 +2440,7 @@
         <p:spPr>
           <a:xfrm>
             <a:off x="457200" y="6356520"/>
-            <a:ext cx="2131920" cy="363240"/>
+            <a:ext cx="2131560" cy="362880"/>
           </a:xfrm>
           <a:prstGeom prst="rect">
             <a:avLst/>
@@ -2746,7 +2746,7 @@
         <p:spPr>
           <a:xfrm>
             <a:off x="0" y="0"/>
-            <a:ext cx="12189960" cy="501120"/>
+            <a:ext cx="12189600" cy="500760"/>
           </a:xfrm>
           <a:prstGeom prst="rect">
             <a:avLst/>
@@ -2787,7 +2787,7 @@
         <p:spPr>
           <a:xfrm>
             <a:off x="594360" y="1051560"/>
-            <a:ext cx="10788120" cy="731160"/>
+            <a:ext cx="10787760" cy="731160"/>
           </a:xfrm>
           <a:prstGeom prst="rect">
             <a:avLst/>
@@ -2804,7 +2804,7 @@
           <a:fontRef idx="minor"/>
         </p:style>
         <p:txBody>
-          <a:bodyPr lIns="146160" rIns="146160" tIns="91440" bIns="91440" anchor="t">
+          <a:bodyPr lIns="164520" rIns="164520" tIns="91440" bIns="91440" anchor="t">
             <a:spAutoFit/>
           </a:bodyPr>
           <a:p>
@@ -2839,7 +2839,7 @@
         <p:spPr>
           <a:xfrm>
             <a:off x="594360" y="1600200"/>
-            <a:ext cx="9325080" cy="548280"/>
+            <a:ext cx="9324720" cy="548280"/>
           </a:xfrm>
           <a:prstGeom prst="rect">
             <a:avLst/>
@@ -2856,7 +2856,7 @@
           <a:fontRef idx="minor"/>
         </p:style>
         <p:txBody>
-          <a:bodyPr lIns="146160" rIns="146160" tIns="91440" bIns="91440" anchor="t">
+          <a:bodyPr lIns="164520" rIns="164520" tIns="91440" bIns="91440" anchor="t">
             <a:spAutoFit/>
           </a:bodyPr>
           <a:p>
@@ -2891,7 +2891,7 @@
         <p:spPr>
           <a:xfrm>
             <a:off x="594360" y="2514600"/>
-            <a:ext cx="9599400" cy="517680"/>
+            <a:ext cx="9599040" cy="517680"/>
           </a:xfrm>
           <a:prstGeom prst="rect">
             <a:avLst/>
@@ -2908,7 +2908,7 @@
           <a:fontRef idx="minor"/>
         </p:style>
         <p:txBody>
-          <a:bodyPr lIns="146160" rIns="146160" tIns="91440" bIns="91440" anchor="t">
+          <a:bodyPr lIns="164520" rIns="164520" tIns="91440" bIns="91440" anchor="t">
             <a:spAutoFit/>
           </a:bodyPr>
           <a:p>
@@ -2943,7 +2943,7 @@
         <p:spPr>
           <a:xfrm>
             <a:off x="594360" y="3127320"/>
-            <a:ext cx="4935960" cy="1663560"/>
+            <a:ext cx="4935600" cy="1663200"/>
           </a:xfrm>
           <a:prstGeom prst="rect">
             <a:avLst/>
@@ -2982,7 +2982,7 @@
             <a:noAutofit/>
           </a:bodyPr>
           <a:p>
-            <a:pPr algn="ctr">
+            <a:pPr>
               <a:lnSpc>
                 <a:spcPct val="100000"/>
               </a:lnSpc>
@@ -3040,7 +3040,7 @@
         <p:spPr>
           <a:xfrm>
             <a:off x="5897880" y="3127320"/>
-            <a:ext cx="4935960" cy="1663560"/>
+            <a:ext cx="4935600" cy="1663200"/>
           </a:xfrm>
           <a:prstGeom prst="rect">
             <a:avLst/>
@@ -3079,7 +3079,7 @@
             <a:noAutofit/>
           </a:bodyPr>
           <a:p>
-            <a:pPr algn="ctr">
+            <a:pPr>
               <a:lnSpc>
                 <a:spcPct val="100000"/>
               </a:lnSpc>
@@ -3137,7 +3137,7 @@
         <p:spPr>
           <a:xfrm>
             <a:off x="594360" y="5806440"/>
-            <a:ext cx="9873720" cy="358920"/>
+            <a:ext cx="9873360" cy="358920"/>
           </a:xfrm>
           <a:prstGeom prst="rect">
             <a:avLst/>
@@ -3219,7 +3219,7 @@
         <p:spPr>
           <a:xfrm>
             <a:off x="0" y="0"/>
-            <a:ext cx="12189960" cy="565200"/>
+            <a:ext cx="12189600" cy="564840"/>
           </a:xfrm>
           <a:prstGeom prst="rect">
             <a:avLst/>
@@ -3260,7 +3260,7 @@
         <p:spPr>
           <a:xfrm>
             <a:off x="347400" y="73080"/>
-            <a:ext cx="9873720" cy="480960"/>
+            <a:ext cx="9873360" cy="480960"/>
           </a:xfrm>
           <a:prstGeom prst="rect">
             <a:avLst/>
@@ -3312,7 +3312,7 @@
         <p:spPr>
           <a:xfrm>
             <a:off x="10652760" y="82440"/>
-            <a:ext cx="1095480" cy="420120"/>
+            <a:ext cx="1095120" cy="420120"/>
           </a:xfrm>
           <a:prstGeom prst="rect">
             <a:avLst/>
@@ -4699,7 +4699,7 @@
         <p:spPr>
           <a:xfrm>
             <a:off x="822960" y="4224600"/>
-            <a:ext cx="4935960" cy="1352520"/>
+            <a:ext cx="4935600" cy="1352160"/>
           </a:xfrm>
           <a:prstGeom prst="rect">
             <a:avLst/>
@@ -4738,7 +4738,7 @@
             <a:noAutofit/>
           </a:bodyPr>
           <a:p>
-            <a:pPr algn="ctr">
+            <a:pPr>
               <a:lnSpc>
                 <a:spcPct val="100000"/>
               </a:lnSpc>
@@ -4796,7 +4796,7 @@
         <p:spPr>
           <a:xfrm>
             <a:off x="6263640" y="4224600"/>
-            <a:ext cx="4935960" cy="1352520"/>
+            <a:ext cx="4935600" cy="1352160"/>
           </a:xfrm>
           <a:prstGeom prst="rect">
             <a:avLst/>
@@ -4835,7 +4835,7 @@
             <a:noAutofit/>
           </a:bodyPr>
           <a:p>
-            <a:pPr algn="ctr">
+            <a:pPr>
               <a:lnSpc>
                 <a:spcPct val="100000"/>
               </a:lnSpc>
@@ -4923,7 +4923,7 @@
         <p:spPr>
           <a:xfrm>
             <a:off x="0" y="0"/>
-            <a:ext cx="12189960" cy="565200"/>
+            <a:ext cx="12189600" cy="564840"/>
           </a:xfrm>
           <a:prstGeom prst="rect">
             <a:avLst/>
@@ -4964,7 +4964,7 @@
         <p:spPr>
           <a:xfrm>
             <a:off x="347400" y="73080"/>
-            <a:ext cx="9873720" cy="480960"/>
+            <a:ext cx="9873360" cy="480960"/>
           </a:xfrm>
           <a:prstGeom prst="rect">
             <a:avLst/>
@@ -5016,7 +5016,7 @@
         <p:spPr>
           <a:xfrm>
             <a:off x="10652760" y="82440"/>
-            <a:ext cx="1095480" cy="420120"/>
+            <a:ext cx="1095120" cy="420120"/>
           </a:xfrm>
           <a:prstGeom prst="rect">
             <a:avLst/>
@@ -7606,7 +7606,7 @@
         <p:spPr>
           <a:xfrm>
             <a:off x="640080" y="5687640"/>
-            <a:ext cx="10971000" cy="380520"/>
+            <a:ext cx="10970640" cy="380520"/>
           </a:xfrm>
           <a:prstGeom prst="rect">
             <a:avLst/>
@@ -7627,7 +7627,7 @@
             <a:spAutoFit/>
           </a:bodyPr>
           <a:p>
-            <a:pPr algn="ctr">
+            <a:pPr>
               <a:lnSpc>
                 <a:spcPct val="100000"/>
               </a:lnSpc>
@@ -7691,7 +7691,7 @@
         <p:spPr>
           <a:xfrm>
             <a:off x="0" y="0"/>
-            <a:ext cx="12189960" cy="565200"/>
+            <a:ext cx="12189600" cy="564840"/>
           </a:xfrm>
           <a:prstGeom prst="rect">
             <a:avLst/>
@@ -7732,7 +7732,7 @@
         <p:spPr>
           <a:xfrm>
             <a:off x="347400" y="73080"/>
-            <a:ext cx="9873720" cy="480960"/>
+            <a:ext cx="9873360" cy="480960"/>
           </a:xfrm>
           <a:prstGeom prst="rect">
             <a:avLst/>
@@ -7784,7 +7784,7 @@
         <p:spPr>
           <a:xfrm>
             <a:off x="10652760" y="82440"/>
-            <a:ext cx="1095480" cy="420120"/>
+            <a:ext cx="1095120" cy="420120"/>
           </a:xfrm>
           <a:prstGeom prst="rect">
             <a:avLst/>
@@ -7836,7 +7836,7 @@
         <p:spPr>
           <a:xfrm>
             <a:off x="777240" y="1005840"/>
-            <a:ext cx="3061440" cy="1334160"/>
+            <a:ext cx="3061080" cy="1333800"/>
           </a:xfrm>
           <a:prstGeom prst="rect">
             <a:avLst/>
@@ -7871,11 +7871,11 @@
           <a:fontRef idx="minor"/>
         </p:style>
         <p:txBody>
-          <a:bodyPr lIns="146160" rIns="146160" tIns="91440" bIns="91440" anchor="ctr">
+          <a:bodyPr lIns="164520" rIns="164520" tIns="91440" bIns="91440" anchor="ctr">
             <a:noAutofit/>
           </a:bodyPr>
           <a:p>
-            <a:pPr algn="ctr">
+            <a:pPr>
               <a:lnSpc>
                 <a:spcPct val="100000"/>
               </a:lnSpc>
@@ -7899,7 +7899,7 @@
             </a:endParaRPr>
           </a:p>
           <a:p>
-            <a:pPr algn="ctr">
+            <a:pPr>
               <a:lnSpc>
                 <a:spcPct val="100000"/>
               </a:lnSpc>
@@ -7933,7 +7933,7 @@
         <p:spPr>
           <a:xfrm>
             <a:off x="4526280" y="1005840"/>
-            <a:ext cx="3061440" cy="1334160"/>
+            <a:ext cx="3061080" cy="1333800"/>
           </a:xfrm>
           <a:prstGeom prst="rect">
             <a:avLst/>
@@ -7968,11 +7968,11 @@
           <a:fontRef idx="minor"/>
         </p:style>
         <p:txBody>
-          <a:bodyPr lIns="146160" rIns="146160" tIns="91440" bIns="91440" anchor="ctr">
+          <a:bodyPr lIns="164520" rIns="164520" tIns="91440" bIns="91440" anchor="ctr">
             <a:noAutofit/>
           </a:bodyPr>
           <a:p>
-            <a:pPr algn="ctr">
+            <a:pPr>
               <a:lnSpc>
                 <a:spcPct val="100000"/>
               </a:lnSpc>
@@ -7996,7 +7996,7 @@
             </a:endParaRPr>
           </a:p>
           <a:p>
-            <a:pPr algn="ctr">
+            <a:pPr>
               <a:lnSpc>
                 <a:spcPct val="100000"/>
               </a:lnSpc>
@@ -8030,7 +8030,7 @@
         <p:spPr>
           <a:xfrm>
             <a:off x="8275320" y="1005840"/>
-            <a:ext cx="3061440" cy="1334160"/>
+            <a:ext cx="3061080" cy="1333800"/>
           </a:xfrm>
           <a:prstGeom prst="rect">
             <a:avLst/>
@@ -8065,11 +8065,11 @@
           <a:fontRef idx="minor"/>
         </p:style>
         <p:txBody>
-          <a:bodyPr lIns="146160" rIns="146160" tIns="91440" bIns="91440" anchor="ctr">
+          <a:bodyPr lIns="164520" rIns="164520" tIns="91440" bIns="91440" anchor="ctr">
             <a:noAutofit/>
           </a:bodyPr>
           <a:p>
-            <a:pPr algn="ctr">
+            <a:pPr>
               <a:lnSpc>
                 <a:spcPct val="100000"/>
               </a:lnSpc>
@@ -8093,7 +8093,7 @@
             </a:endParaRPr>
           </a:p>
           <a:p>
-            <a:pPr algn="ctr">
+            <a:pPr>
               <a:lnSpc>
                 <a:spcPct val="100000"/>
               </a:lnSpc>
@@ -8127,7 +8127,7 @@
         <p:spPr>
           <a:xfrm>
             <a:off x="822960" y="2834640"/>
-            <a:ext cx="4981680" cy="1416600"/>
+            <a:ext cx="4981320" cy="1416240"/>
           </a:xfrm>
           <a:prstGeom prst="rect">
             <a:avLst/>
@@ -8166,7 +8166,7 @@
             <a:noAutofit/>
           </a:bodyPr>
           <a:p>
-            <a:pPr algn="ctr">
+            <a:pPr>
               <a:lnSpc>
                 <a:spcPct val="100000"/>
               </a:lnSpc>
@@ -8224,7 +8224,7 @@
         <p:spPr>
           <a:xfrm>
             <a:off x="6263640" y="2834640"/>
-            <a:ext cx="4981680" cy="1416600"/>
+            <a:ext cx="4981320" cy="1416240"/>
           </a:xfrm>
           <a:prstGeom prst="rect">
             <a:avLst/>
@@ -8263,7 +8263,7 @@
             <a:noAutofit/>
           </a:bodyPr>
           <a:p>
-            <a:pPr algn="ctr">
+            <a:pPr>
               <a:lnSpc>
                 <a:spcPct val="100000"/>
               </a:lnSpc>
@@ -8321,7 +8321,7 @@
         <p:spPr>
           <a:xfrm>
             <a:off x="777240" y="4956120"/>
-            <a:ext cx="10743840" cy="633240"/>
+            <a:ext cx="10743480" cy="633240"/>
           </a:xfrm>
           <a:prstGeom prst="rect">
             <a:avLst/>
@@ -8343,7 +8343,7 @@
           <a:fontRef idx="minor"/>
         </p:style>
         <p:txBody>
-          <a:bodyPr lIns="182880" rIns="182880" tIns="91440" bIns="91440" anchor="t">
+          <a:bodyPr lIns="164520" rIns="164520" tIns="91440" bIns="91440" anchor="t">
             <a:spAutoFit/>
           </a:bodyPr>
           <a:p>
@@ -8408,7 +8408,7 @@
         <p:spPr>
           <a:xfrm>
             <a:off x="0" y="0"/>
-            <a:ext cx="12189960" cy="565200"/>
+            <a:ext cx="12189600" cy="564840"/>
           </a:xfrm>
           <a:prstGeom prst="rect">
             <a:avLst/>
@@ -8449,7 +8449,7 @@
         <p:spPr>
           <a:xfrm>
             <a:off x="347400" y="73080"/>
-            <a:ext cx="9873720" cy="480960"/>
+            <a:ext cx="9873360" cy="480960"/>
           </a:xfrm>
           <a:prstGeom prst="rect">
             <a:avLst/>
@@ -8501,7 +8501,7 @@
         <p:spPr>
           <a:xfrm>
             <a:off x="10652760" y="82440"/>
-            <a:ext cx="1095480" cy="420120"/>
+            <a:ext cx="1095120" cy="420120"/>
           </a:xfrm>
           <a:prstGeom prst="rect">
             <a:avLst/>
@@ -8557,7 +8557,7 @@
         <p:spPr>
           <a:xfrm>
             <a:off x="640080" y="749880"/>
-            <a:ext cx="10925280" cy="3838680"/>
+            <a:ext cx="10924920" cy="3838320"/>
           </a:xfrm>
           <a:prstGeom prst="rect">
             <a:avLst/>
@@ -8576,7 +8576,7 @@
         <p:spPr>
           <a:xfrm>
             <a:off x="822960" y="4736520"/>
-            <a:ext cx="10559880" cy="1389240"/>
+            <a:ext cx="10559520" cy="1388880"/>
           </a:xfrm>
           <a:prstGeom prst="rect">
             <a:avLst/>
@@ -8619,7 +8619,7 @@
         <p:spPr>
           <a:xfrm>
             <a:off x="932760" y="4855320"/>
-            <a:ext cx="10340280" cy="230760"/>
+            <a:ext cx="10339920" cy="230760"/>
           </a:xfrm>
           <a:prstGeom prst="rect">
             <a:avLst/>
@@ -8640,7 +8640,7 @@
             <a:spAutoFit/>
           </a:bodyPr>
           <a:p>
-            <a:pPr algn="ctr">
+            <a:pPr>
               <a:lnSpc>
                 <a:spcPct val="100000"/>
               </a:lnSpc>
@@ -8671,7 +8671,7 @@
         <p:spPr>
           <a:xfrm>
             <a:off x="987480" y="5248800"/>
-            <a:ext cx="10230840" cy="507960"/>
+            <a:ext cx="10230480" cy="617400"/>
           </a:xfrm>
           <a:prstGeom prst="rect">
             <a:avLst/>
@@ -8688,7 +8688,7 @@
           <a:fontRef idx="minor"/>
         </p:style>
         <p:txBody>
-          <a:bodyPr lIns="73080" rIns="73080" tIns="36720" bIns="36720" anchor="t">
+          <a:bodyPr lIns="164520" rIns="164520" tIns="91440" bIns="91440" anchor="t">
             <a:spAutoFit/>
           </a:bodyPr>
           <a:p>
@@ -8756,7 +8756,7 @@
         <p:spPr>
           <a:xfrm>
             <a:off x="0" y="0"/>
-            <a:ext cx="12189960" cy="565200"/>
+            <a:ext cx="12189600" cy="564840"/>
           </a:xfrm>
           <a:prstGeom prst="rect">
             <a:avLst/>
@@ -8797,7 +8797,7 @@
         <p:spPr>
           <a:xfrm>
             <a:off x="347400" y="73080"/>
-            <a:ext cx="9873720" cy="480960"/>
+            <a:ext cx="9873360" cy="480960"/>
           </a:xfrm>
           <a:prstGeom prst="rect">
             <a:avLst/>
@@ -8849,7 +8849,7 @@
         <p:spPr>
           <a:xfrm>
             <a:off x="10652760" y="82440"/>
-            <a:ext cx="1095480" cy="420120"/>
+            <a:ext cx="1095120" cy="420120"/>
           </a:xfrm>
           <a:prstGeom prst="rect">
             <a:avLst/>
@@ -9556,7 +9556,7 @@
         <p:spPr>
           <a:xfrm>
             <a:off x="914400" y="4827960"/>
-            <a:ext cx="10330920" cy="1169640"/>
+            <a:ext cx="10330560" cy="1169280"/>
           </a:xfrm>
           <a:prstGeom prst="rect">
             <a:avLst/>
@@ -9591,11 +9591,11 @@
           <a:fontRef idx="minor"/>
         </p:style>
         <p:txBody>
-          <a:bodyPr lIns="182880" rIns="182880" tIns="91440" bIns="91440" anchor="ctr">
+          <a:bodyPr lIns="164520" rIns="164520" tIns="91440" bIns="91440" anchor="ctr">
             <a:noAutofit/>
           </a:bodyPr>
           <a:p>
-            <a:pPr algn="ctr">
+            <a:pPr>
               <a:lnSpc>
                 <a:spcPct val="100000"/>
               </a:lnSpc>
@@ -9683,7 +9683,7 @@
         <p:spPr>
           <a:xfrm>
             <a:off x="0" y="0"/>
-            <a:ext cx="12189960" cy="565200"/>
+            <a:ext cx="12189600" cy="564840"/>
           </a:xfrm>
           <a:prstGeom prst="rect">
             <a:avLst/>
@@ -9724,7 +9724,7 @@
         <p:spPr>
           <a:xfrm>
             <a:off x="347400" y="73080"/>
-            <a:ext cx="9873720" cy="480960"/>
+            <a:ext cx="9873360" cy="480960"/>
           </a:xfrm>
           <a:prstGeom prst="rect">
             <a:avLst/>
@@ -9776,7 +9776,7 @@
         <p:spPr>
           <a:xfrm>
             <a:off x="10652760" y="82440"/>
-            <a:ext cx="1095480" cy="420120"/>
+            <a:ext cx="1095120" cy="420120"/>
           </a:xfrm>
           <a:prstGeom prst="rect">
             <a:avLst/>
@@ -9828,7 +9828,7 @@
         <p:spPr>
           <a:xfrm>
             <a:off x="731520" y="868680"/>
-            <a:ext cx="10742400" cy="1114920"/>
+            <a:ext cx="10742040" cy="1114560"/>
           </a:xfrm>
           <a:prstGeom prst="rect">
             <a:avLst/>
@@ -9867,7 +9867,7 @@
             <a:noAutofit/>
           </a:bodyPr>
           <a:p>
-            <a:pPr algn="ctr">
+            <a:pPr>
               <a:lnSpc>
                 <a:spcPct val="100000"/>
               </a:lnSpc>
@@ -9925,7 +9925,7 @@
         <p:spPr>
           <a:xfrm>
             <a:off x="731520" y="2267640"/>
-            <a:ext cx="10742400" cy="1114920"/>
+            <a:ext cx="10742040" cy="1114560"/>
           </a:xfrm>
           <a:prstGeom prst="rect">
             <a:avLst/>
@@ -9964,7 +9964,7 @@
             <a:noAutofit/>
           </a:bodyPr>
           <a:p>
-            <a:pPr algn="ctr">
+            <a:pPr>
               <a:lnSpc>
                 <a:spcPct val="100000"/>
               </a:lnSpc>
@@ -10022,7 +10022,7 @@
         <p:spPr>
           <a:xfrm>
             <a:off x="731520" y="3666600"/>
-            <a:ext cx="10742400" cy="1114920"/>
+            <a:ext cx="10742040" cy="1114560"/>
           </a:xfrm>
           <a:prstGeom prst="rect">
             <a:avLst/>
@@ -10061,7 +10061,7 @@
             <a:noAutofit/>
           </a:bodyPr>
           <a:p>
-            <a:pPr algn="ctr">
+            <a:pPr>
               <a:lnSpc>
                 <a:spcPct val="100000"/>
               </a:lnSpc>
@@ -10119,7 +10119,7 @@
         <p:spPr>
           <a:xfrm>
             <a:off x="868680" y="5321880"/>
-            <a:ext cx="10423800" cy="633240"/>
+            <a:ext cx="10423440" cy="633240"/>
           </a:xfrm>
           <a:prstGeom prst="rect">
             <a:avLst/>
@@ -10141,7 +10141,7 @@
           <a:fontRef idx="minor"/>
         </p:style>
         <p:txBody>
-          <a:bodyPr lIns="182880" rIns="182880" tIns="91440" bIns="91440" anchor="t">
+          <a:bodyPr lIns="164520" rIns="164520" tIns="91440" bIns="91440" anchor="t">
             <a:spAutoFit/>
           </a:bodyPr>
           <a:p>
@@ -10206,7 +10206,7 @@
         <p:spPr>
           <a:xfrm>
             <a:off x="0" y="0"/>
-            <a:ext cx="12189960" cy="565200"/>
+            <a:ext cx="12189600" cy="564840"/>
           </a:xfrm>
           <a:prstGeom prst="rect">
             <a:avLst/>
@@ -10247,7 +10247,7 @@
         <p:spPr>
           <a:xfrm>
             <a:off x="347400" y="73080"/>
-            <a:ext cx="9873720" cy="480960"/>
+            <a:ext cx="9873360" cy="480960"/>
           </a:xfrm>
           <a:prstGeom prst="rect">
             <a:avLst/>
@@ -10299,7 +10299,7 @@
         <p:spPr>
           <a:xfrm>
             <a:off x="10652760" y="82440"/>
-            <a:ext cx="1095480" cy="420120"/>
+            <a:ext cx="1095120" cy="420120"/>
           </a:xfrm>
           <a:prstGeom prst="rect">
             <a:avLst/>
@@ -10351,7 +10351,7 @@
         <p:spPr>
           <a:xfrm>
             <a:off x="777240" y="896040"/>
-            <a:ext cx="10697760" cy="840600"/>
+            <a:ext cx="10697400" cy="840240"/>
           </a:xfrm>
           <a:prstGeom prst="roundRect">
             <a:avLst>
@@ -10387,7 +10387,7 @@
           <a:fontRef idx="minor"/>
         </p:style>
         <p:txBody>
-          <a:bodyPr lIns="182880" rIns="182880" tIns="109800" bIns="109800" anchor="ctr">
+          <a:bodyPr lIns="164520" rIns="164520" tIns="91440" bIns="91440" anchor="ctr">
             <a:noAutofit/>
           </a:bodyPr>
           <a:p>
@@ -10446,7 +10446,7 @@
         <p:spPr>
           <a:xfrm>
             <a:off x="777240" y="1993320"/>
-            <a:ext cx="5165640" cy="1352520"/>
+            <a:ext cx="5165280" cy="1352160"/>
           </a:xfrm>
           <a:prstGeom prst="roundRect">
             <a:avLst>
@@ -10482,7 +10482,7 @@
           <a:fontRef idx="minor"/>
         </p:style>
         <p:txBody>
-          <a:bodyPr lIns="182880" rIns="182880" tIns="109800" bIns="109800" anchor="ctr">
+          <a:bodyPr lIns="164520" rIns="164520" tIns="91440" bIns="91440" anchor="ctr">
             <a:noAutofit/>
           </a:bodyPr>
           <a:p>
@@ -10541,7 +10541,7 @@
         <p:spPr>
           <a:xfrm>
             <a:off x="6263640" y="1993320"/>
-            <a:ext cx="5165640" cy="1352520"/>
+            <a:ext cx="5165280" cy="1352160"/>
           </a:xfrm>
           <a:prstGeom prst="roundRect">
             <a:avLst>
@@ -10577,7 +10577,7 @@
           <a:fontRef idx="minor"/>
         </p:style>
         <p:txBody>
-          <a:bodyPr lIns="182880" rIns="182880" tIns="109800" bIns="109800" anchor="ctr">
+          <a:bodyPr lIns="164520" rIns="164520" tIns="91440" bIns="91440" anchor="ctr">
             <a:noAutofit/>
           </a:bodyPr>
           <a:p>
@@ -10636,7 +10636,7 @@
         <p:spPr>
           <a:xfrm>
             <a:off x="777240" y="3675960"/>
-            <a:ext cx="5165640" cy="1352520"/>
+            <a:ext cx="5165280" cy="1352160"/>
           </a:xfrm>
           <a:prstGeom prst="roundRect">
             <a:avLst>
@@ -10672,7 +10672,7 @@
           <a:fontRef idx="minor"/>
         </p:style>
         <p:txBody>
-          <a:bodyPr lIns="182880" rIns="182880" tIns="109800" bIns="109800" anchor="ctr">
+          <a:bodyPr lIns="164520" rIns="164520" tIns="91440" bIns="91440" anchor="ctr">
             <a:noAutofit/>
           </a:bodyPr>
           <a:p>
@@ -10731,7 +10731,7 @@
         <p:spPr>
           <a:xfrm>
             <a:off x="6263640" y="3675960"/>
-            <a:ext cx="5165640" cy="1352520"/>
+            <a:ext cx="5165280" cy="1352160"/>
           </a:xfrm>
           <a:prstGeom prst="roundRect">
             <a:avLst>
@@ -10767,7 +10767,7 @@
           <a:fontRef idx="minor"/>
         </p:style>
         <p:txBody>
-          <a:bodyPr lIns="182880" rIns="182880" tIns="109800" bIns="109800" anchor="ctr">
+          <a:bodyPr lIns="164520" rIns="164520" tIns="91440" bIns="91440" anchor="ctr">
             <a:noAutofit/>
           </a:bodyPr>
           <a:p>
@@ -10826,7 +10826,7 @@
         <p:spPr>
           <a:xfrm>
             <a:off x="1005840" y="5596200"/>
-            <a:ext cx="10194840" cy="694080"/>
+            <a:ext cx="10194480" cy="693720"/>
           </a:xfrm>
           <a:prstGeom prst="roundRect">
             <a:avLst>
@@ -10862,7 +10862,7 @@
           <a:fontRef idx="minor"/>
         </p:style>
         <p:txBody>
-          <a:bodyPr lIns="182880" rIns="182880" tIns="109800" bIns="109800" anchor="ctr">
+          <a:bodyPr lIns="164520" rIns="164520" tIns="91440" bIns="91440" anchor="ctr">
             <a:noAutofit/>
           </a:bodyPr>
           <a:p>
@@ -10951,7 +10951,7 @@
         <p:spPr>
           <a:xfrm>
             <a:off x="0" y="0"/>
-            <a:ext cx="12189960" cy="565200"/>
+            <a:ext cx="12189600" cy="564840"/>
           </a:xfrm>
           <a:prstGeom prst="rect">
             <a:avLst/>
@@ -10992,7 +10992,7 @@
         <p:spPr>
           <a:xfrm>
             <a:off x="347400" y="73080"/>
-            <a:ext cx="9873720" cy="480960"/>
+            <a:ext cx="9873360" cy="480960"/>
           </a:xfrm>
           <a:prstGeom prst="rect">
             <a:avLst/>
@@ -11044,7 +11044,7 @@
         <p:spPr>
           <a:xfrm>
             <a:off x="10652760" y="82440"/>
-            <a:ext cx="1095480" cy="420120"/>
+            <a:ext cx="1095120" cy="420120"/>
           </a:xfrm>
           <a:prstGeom prst="rect">
             <a:avLst/>
@@ -11096,7 +11096,7 @@
         <p:spPr>
           <a:xfrm>
             <a:off x="731520" y="896040"/>
-            <a:ext cx="10697760" cy="1078200"/>
+            <a:ext cx="10697400" cy="1077840"/>
           </a:xfrm>
           <a:prstGeom prst="rect">
             <a:avLst/>
@@ -11135,7 +11135,7 @@
             <a:noAutofit/>
           </a:bodyPr>
           <a:p>
-            <a:pPr algn="ctr">
+            <a:pPr>
               <a:lnSpc>
                 <a:spcPct val="100000"/>
               </a:lnSpc>
@@ -11193,7 +11193,7 @@
         <p:spPr>
           <a:xfrm>
             <a:off x="731520" y="2359080"/>
-            <a:ext cx="10697760" cy="1078200"/>
+            <a:ext cx="10697400" cy="1077840"/>
           </a:xfrm>
           <a:prstGeom prst="rect">
             <a:avLst/>
@@ -11232,7 +11232,7 @@
             <a:noAutofit/>
           </a:bodyPr>
           <a:p>
-            <a:pPr algn="ctr">
+            <a:pPr>
               <a:lnSpc>
                 <a:spcPct val="100000"/>
               </a:lnSpc>
@@ -11290,7 +11290,7 @@
         <p:spPr>
           <a:xfrm>
             <a:off x="731520" y="3822120"/>
-            <a:ext cx="10697760" cy="1078200"/>
+            <a:ext cx="10697400" cy="1077840"/>
           </a:xfrm>
           <a:prstGeom prst="rect">
             <a:avLst/>
@@ -11329,7 +11329,7 @@
             <a:noAutofit/>
           </a:bodyPr>
           <a:p>
-            <a:pPr algn="ctr">
+            <a:pPr>
               <a:lnSpc>
                 <a:spcPct val="100000"/>
               </a:lnSpc>
@@ -11387,7 +11387,7 @@
         <p:spPr>
           <a:xfrm>
             <a:off x="868680" y="5413320"/>
-            <a:ext cx="10239480" cy="608760"/>
+            <a:ext cx="10239120" cy="608760"/>
           </a:xfrm>
           <a:prstGeom prst="rect">
             <a:avLst/>
@@ -11472,7 +11472,7 @@
         <p:spPr>
           <a:xfrm>
             <a:off x="0" y="0"/>
-            <a:ext cx="12189960" cy="565200"/>
+            <a:ext cx="12189600" cy="564840"/>
           </a:xfrm>
           <a:prstGeom prst="rect">
             <a:avLst/>
@@ -11513,7 +11513,7 @@
         <p:spPr>
           <a:xfrm>
             <a:off x="347400" y="73080"/>
-            <a:ext cx="9873720" cy="480960"/>
+            <a:ext cx="9873360" cy="480960"/>
           </a:xfrm>
           <a:prstGeom prst="rect">
             <a:avLst/>
@@ -11565,7 +11565,7 @@
         <p:spPr>
           <a:xfrm>
             <a:off x="10652760" y="82440"/>
-            <a:ext cx="1095480" cy="420120"/>
+            <a:ext cx="1095120" cy="420120"/>
           </a:xfrm>
           <a:prstGeom prst="rect">
             <a:avLst/>
@@ -11617,7 +11617,7 @@
         <p:spPr>
           <a:xfrm>
             <a:off x="822960" y="1005840"/>
-            <a:ext cx="4935960" cy="3198960"/>
+            <a:ext cx="4935600" cy="3198960"/>
           </a:xfrm>
           <a:prstGeom prst="rect">
             <a:avLst/>
@@ -11634,7 +11634,7 @@
           <a:fontRef idx="minor"/>
         </p:style>
         <p:txBody>
-          <a:bodyPr lIns="146160" rIns="146160" tIns="91440" bIns="91440" anchor="t">
+          <a:bodyPr lIns="164520" rIns="164520" tIns="91440" bIns="91440" anchor="t">
             <a:spAutoFit/>
           </a:bodyPr>
           <a:p>
@@ -11733,7 +11733,7 @@
         <p:spPr>
           <a:xfrm>
             <a:off x="6080760" y="960120"/>
-            <a:ext cx="4799520" cy="1663200"/>
+            <a:ext cx="4799160" cy="1662840"/>
           </a:xfrm>
           <a:prstGeom prst="rect">
             <a:avLst/>
@@ -11772,7 +11772,7 @@
             <a:noAutofit/>
           </a:bodyPr>
           <a:p>
-            <a:pPr algn="ctr">
+            <a:pPr>
               <a:lnSpc>
                 <a:spcPct val="100000"/>
               </a:lnSpc>
@@ -11854,7 +11854,7 @@
         <p:spPr>
           <a:xfrm>
             <a:off x="6080760" y="3017520"/>
-            <a:ext cx="4799520" cy="1297440"/>
+            <a:ext cx="4799160" cy="1297080"/>
           </a:xfrm>
           <a:prstGeom prst="rect">
             <a:avLst/>
@@ -11893,7 +11893,7 @@
             <a:noAutofit/>
           </a:bodyPr>
           <a:p>
-            <a:pPr algn="ctr">
+            <a:pPr>
               <a:lnSpc>
                 <a:spcPct val="100000"/>
               </a:lnSpc>
@@ -11951,7 +11951,7 @@
         <p:spPr>
           <a:xfrm>
             <a:off x="960120" y="4800600"/>
-            <a:ext cx="4890240" cy="840600"/>
+            <a:ext cx="4889880" cy="840240"/>
           </a:xfrm>
           <a:prstGeom prst="rect">
             <a:avLst/>
@@ -11990,7 +11990,7 @@
             <a:noAutofit/>
           </a:bodyPr>
           <a:p>
-            <a:pPr algn="ctr">
+            <a:pPr>
               <a:lnSpc>
                 <a:spcPct val="100000"/>
               </a:lnSpc>
@@ -12048,7 +12048,7 @@
         <p:spPr>
           <a:xfrm>
             <a:off x="5989320" y="4800600"/>
-            <a:ext cx="4890240" cy="840600"/>
+            <a:ext cx="4889880" cy="840240"/>
           </a:xfrm>
           <a:prstGeom prst="rect">
             <a:avLst/>
@@ -12087,7 +12087,7 @@
             <a:noAutofit/>
           </a:bodyPr>
           <a:p>
-            <a:pPr algn="ctr">
+            <a:pPr>
               <a:lnSpc>
                 <a:spcPct val="100000"/>
               </a:lnSpc>
@@ -12175,7 +12175,7 @@
         <p:spPr>
           <a:xfrm>
             <a:off x="0" y="0"/>
-            <a:ext cx="12189960" cy="565200"/>
+            <a:ext cx="12189600" cy="564840"/>
           </a:xfrm>
           <a:prstGeom prst="rect">
             <a:avLst/>
@@ -12216,7 +12216,7 @@
         <p:spPr>
           <a:xfrm>
             <a:off x="347400" y="73080"/>
-            <a:ext cx="9873720" cy="480960"/>
+            <a:ext cx="9873360" cy="480960"/>
           </a:xfrm>
           <a:prstGeom prst="rect">
             <a:avLst/>
@@ -12268,7 +12268,7 @@
         <p:spPr>
           <a:xfrm>
             <a:off x="10652760" y="82440"/>
-            <a:ext cx="1095480" cy="420120"/>
+            <a:ext cx="1095120" cy="420120"/>
           </a:xfrm>
           <a:prstGeom prst="rect">
             <a:avLst/>
@@ -13133,7 +13133,7 @@
         <p:spPr>
           <a:xfrm>
             <a:off x="822960" y="4754880"/>
-            <a:ext cx="10559520" cy="1114920"/>
+            <a:ext cx="10559160" cy="1114560"/>
           </a:xfrm>
           <a:prstGeom prst="rect">
             <a:avLst/>
@@ -13168,11 +13168,11 @@
           <a:fontRef idx="minor"/>
         </p:style>
         <p:txBody>
-          <a:bodyPr lIns="182880" rIns="182880" tIns="91440" bIns="91440" anchor="ctr">
+          <a:bodyPr lIns="164520" rIns="164520" tIns="91440" bIns="91440" anchor="ctr">
             <a:noAutofit/>
           </a:bodyPr>
           <a:p>
-            <a:pPr algn="ctr">
+            <a:pPr>
               <a:lnSpc>
                 <a:spcPct val="100000"/>
               </a:lnSpc>
@@ -13260,7 +13260,7 @@
         <p:spPr>
           <a:xfrm>
             <a:off x="0" y="0"/>
-            <a:ext cx="12189960" cy="565200"/>
+            <a:ext cx="12189600" cy="564840"/>
           </a:xfrm>
           <a:prstGeom prst="rect">
             <a:avLst/>
@@ -13301,7 +13301,7 @@
         <p:spPr>
           <a:xfrm>
             <a:off x="347400" y="73080"/>
-            <a:ext cx="9873720" cy="480960"/>
+            <a:ext cx="9873360" cy="480960"/>
           </a:xfrm>
           <a:prstGeom prst="rect">
             <a:avLst/>
@@ -13353,7 +13353,7 @@
         <p:spPr>
           <a:xfrm>
             <a:off x="10652760" y="82440"/>
-            <a:ext cx="1095480" cy="420120"/>
+            <a:ext cx="1095120" cy="420120"/>
           </a:xfrm>
           <a:prstGeom prst="rect">
             <a:avLst/>
@@ -13405,7 +13405,7 @@
         <p:spPr>
           <a:xfrm>
             <a:off x="685800" y="914400"/>
-            <a:ext cx="5073120" cy="1352520"/>
+            <a:ext cx="5072760" cy="1352160"/>
           </a:xfrm>
           <a:prstGeom prst="rect">
             <a:avLst/>
@@ -13444,7 +13444,7 @@
             <a:noAutofit/>
           </a:bodyPr>
           <a:p>
-            <a:pPr algn="ctr">
+            <a:pPr>
               <a:lnSpc>
                 <a:spcPct val="100000"/>
               </a:lnSpc>
@@ -13468,7 +13468,7 @@
             </a:endParaRPr>
           </a:p>
           <a:p>
-            <a:pPr algn="ctr">
+            <a:pPr>
               <a:lnSpc>
                 <a:spcPct val="100000"/>
               </a:lnSpc>
@@ -13526,7 +13526,7 @@
         <p:spPr>
           <a:xfrm>
             <a:off x="6172200" y="914400"/>
-            <a:ext cx="5073120" cy="1352520"/>
+            <a:ext cx="5072760" cy="1352160"/>
           </a:xfrm>
           <a:prstGeom prst="rect">
             <a:avLst/>
@@ -13565,7 +13565,7 @@
             <a:noAutofit/>
           </a:bodyPr>
           <a:p>
-            <a:pPr algn="ctr">
+            <a:pPr>
               <a:lnSpc>
                 <a:spcPct val="100000"/>
               </a:lnSpc>
@@ -13589,7 +13589,7 @@
             </a:endParaRPr>
           </a:p>
           <a:p>
-            <a:pPr algn="ctr">
+            <a:pPr>
               <a:lnSpc>
                 <a:spcPct val="100000"/>
               </a:lnSpc>
@@ -13647,7 +13647,7 @@
         <p:spPr>
           <a:xfrm>
             <a:off x="685800" y="2761560"/>
-            <a:ext cx="5073120" cy="1352520"/>
+            <a:ext cx="5072760" cy="1352160"/>
           </a:xfrm>
           <a:prstGeom prst="rect">
             <a:avLst/>
@@ -13686,7 +13686,7 @@
             <a:noAutofit/>
           </a:bodyPr>
           <a:p>
-            <a:pPr algn="ctr">
+            <a:pPr>
               <a:lnSpc>
                 <a:spcPct val="100000"/>
               </a:lnSpc>
@@ -13710,7 +13710,7 @@
             </a:endParaRPr>
           </a:p>
           <a:p>
-            <a:pPr algn="ctr">
+            <a:pPr>
               <a:lnSpc>
                 <a:spcPct val="100000"/>
               </a:lnSpc>
@@ -13768,7 +13768,7 @@
         <p:spPr>
           <a:xfrm>
             <a:off x="6172200" y="2761560"/>
-            <a:ext cx="5073120" cy="1352520"/>
+            <a:ext cx="5072760" cy="1352160"/>
           </a:xfrm>
           <a:prstGeom prst="rect">
             <a:avLst/>
@@ -13807,7 +13807,7 @@
             <a:noAutofit/>
           </a:bodyPr>
           <a:p>
-            <a:pPr algn="ctr">
+            <a:pPr>
               <a:lnSpc>
                 <a:spcPct val="100000"/>
               </a:lnSpc>
@@ -13865,7 +13865,7 @@
         <p:spPr>
           <a:xfrm>
             <a:off x="868680" y="5193720"/>
-            <a:ext cx="10422360" cy="608760"/>
+            <a:ext cx="10422000" cy="608760"/>
           </a:xfrm>
           <a:prstGeom prst="rect">
             <a:avLst/>
@@ -13882,11 +13882,11 @@
           <a:fontRef idx="minor"/>
         </p:style>
         <p:txBody>
-          <a:bodyPr lIns="182880" rIns="182880" tIns="91440" bIns="91440" anchor="t">
+          <a:bodyPr lIns="164520" rIns="164520" tIns="91440" bIns="91440" anchor="t">
             <a:spAutoFit/>
           </a:bodyPr>
           <a:p>
-            <a:pPr algn="ctr">
+            <a:pPr>
               <a:lnSpc>
                 <a:spcPct val="100000"/>
               </a:lnSpc>
@@ -13950,7 +13950,7 @@
         <p:spPr>
           <a:xfrm>
             <a:off x="0" y="0"/>
-            <a:ext cx="12189960" cy="565200"/>
+            <a:ext cx="12189600" cy="564840"/>
           </a:xfrm>
           <a:prstGeom prst="rect">
             <a:avLst/>
@@ -13991,7 +13991,7 @@
         <p:spPr>
           <a:xfrm>
             <a:off x="347400" y="73080"/>
-            <a:ext cx="9873720" cy="480960"/>
+            <a:ext cx="9873360" cy="480960"/>
           </a:xfrm>
           <a:prstGeom prst="rect">
             <a:avLst/>
@@ -14043,7 +14043,7 @@
         <p:spPr>
           <a:xfrm>
             <a:off x="10652760" y="82440"/>
-            <a:ext cx="1095480" cy="420120"/>
+            <a:ext cx="1095120" cy="420120"/>
           </a:xfrm>
           <a:prstGeom prst="rect">
             <a:avLst/>
@@ -14095,7 +14095,7 @@
         <p:spPr>
           <a:xfrm>
             <a:off x="502920" y="1225440"/>
-            <a:ext cx="2055600" cy="1443960"/>
+            <a:ext cx="2055240" cy="1443600"/>
           </a:xfrm>
           <a:prstGeom prst="rect">
             <a:avLst/>
@@ -14130,11 +14130,11 @@
           <a:fontRef idx="minor"/>
         </p:style>
         <p:txBody>
-          <a:bodyPr lIns="118800" rIns="118800" tIns="91440" bIns="91440" anchor="ctr">
+          <a:bodyPr lIns="164520" rIns="164520" tIns="91440" bIns="91440" anchor="ctr">
             <a:noAutofit/>
           </a:bodyPr>
           <a:p>
-            <a:pPr algn="ctr">
+            <a:pPr>
               <a:lnSpc>
                 <a:spcPct val="100000"/>
               </a:lnSpc>
@@ -14158,7 +14158,7 @@
             </a:endParaRPr>
           </a:p>
           <a:p>
-            <a:pPr algn="ctr">
+            <a:pPr>
               <a:lnSpc>
                 <a:spcPct val="100000"/>
               </a:lnSpc>
@@ -14216,7 +14216,7 @@
         <p:spPr>
           <a:xfrm>
             <a:off x="2578680" y="1774080"/>
-            <a:ext cx="226800" cy="511560"/>
+            <a:ext cx="226440" cy="511560"/>
           </a:xfrm>
           <a:prstGeom prst="rect">
             <a:avLst/>
@@ -14237,7 +14237,7 @@
             <a:spAutoFit/>
           </a:bodyPr>
           <a:p>
-            <a:pPr algn="ctr">
+            <a:pPr>
               <a:lnSpc>
                 <a:spcPct val="100000"/>
               </a:lnSpc>
@@ -14268,647 +14268,7 @@
         <p:spPr>
           <a:xfrm>
             <a:off x="2834640" y="1225440"/>
-            <a:ext cx="2055600" cy="1443960"/>
-          </a:xfrm>
-          <a:prstGeom prst="rect">
-            <a:avLst/>
-          </a:prstGeom>
-          <a:solidFill>
-            <a:srgbClr val="e0f1ec"/>
-          </a:solidFill>
-          <a:ln w="17780">
-            <a:solidFill>
-              <a:srgbClr val="37917e"/>
-            </a:solidFill>
-            <a:round/>
-          </a:ln>
-          <a:effectLst>
-            <a:outerShdw blurRad="39960" dir="5400000" dist="23040" rotWithShape="0">
-              <a:srgbClr val="000000">
-                <a:alpha val="35000"/>
-              </a:srgbClr>
-            </a:outerShdw>
-          </a:effectLst>
-        </p:spPr>
-        <p:style>
-          <a:lnRef idx="1">
-            <a:schemeClr val="accent1"/>
-          </a:lnRef>
-          <a:fillRef idx="3">
-            <a:schemeClr val="accent1"/>
-          </a:fillRef>
-          <a:effectRef idx="2">
-            <a:schemeClr val="accent1"/>
-          </a:effectRef>
-          <a:fontRef idx="minor"/>
-        </p:style>
-        <p:txBody>
-          <a:bodyPr lIns="118800" rIns="118800" tIns="91440" bIns="91440" anchor="ctr">
-            <a:noAutofit/>
-          </a:bodyPr>
-          <a:p>
-            <a:pPr algn="ctr">
-              <a:lnSpc>
-                <a:spcPct val="100000"/>
-              </a:lnSpc>
-              <a:spcAft>
-                <a:spcPts val="201"/>
-              </a:spcAft>
-              <a:buNone/>
-            </a:pPr>
-            <a:r>
-              <a:rPr b="1" lang="en-US" sz="1280" spc="-1" strike="noStrike">
-                <a:solidFill>
-                  <a:srgbClr val="37917e"/>
-                </a:solidFill>
-                <a:latin typeface="Aptos"/>
-                <a:ea typeface="DejaVu Sans"/>
-              </a:rPr>
-              <a:t>Candidate pool</a:t>
-            </a:r>
-            <a:endParaRPr b="0" lang="en-US" sz="1280" spc="-1" strike="noStrike">
-              <a:latin typeface="Arial"/>
-            </a:endParaRPr>
-          </a:p>
-          <a:p>
-            <a:pPr algn="ctr">
-              <a:lnSpc>
-                <a:spcPct val="100000"/>
-              </a:lnSpc>
-              <a:spcAft>
-                <a:spcPts val="201"/>
-              </a:spcAft>
-              <a:buNone/>
-            </a:pPr>
-            <a:r>
-              <a:rPr b="0" lang="en-US" sz="1280" spc="-1" strike="noStrike">
-                <a:solidFill>
-                  <a:srgbClr val="121b2b"/>
-                </a:solidFill>
-                <a:latin typeface="Aptos"/>
-                <a:ea typeface="DejaVu Sans"/>
-              </a:rPr>
-              <a:t>keyframes + short</a:t>
-            </a:r>
-            <a:endParaRPr b="0" lang="en-US" sz="1280" spc="-1" strike="noStrike">
-              <a:latin typeface="Arial"/>
-            </a:endParaRPr>
-          </a:p>
-          <a:p>
-            <a:pPr>
-              <a:lnSpc>
-                <a:spcPct val="100000"/>
-              </a:lnSpc>
-              <a:spcAft>
-                <a:spcPts val="201"/>
-              </a:spcAft>
-              <a:buNone/>
-            </a:pPr>
-            <a:r>
-              <a:rPr b="0" lang="en-US" sz="1280" spc="-1" strike="noStrike">
-                <a:solidFill>
-                  <a:srgbClr val="121b2b"/>
-                </a:solidFill>
-                <a:latin typeface="Aptos"/>
-                <a:ea typeface="DejaVu Sans"/>
-              </a:rPr>
-              <a:t>temporal segments</a:t>
-            </a:r>
-            <a:endParaRPr b="0" lang="en-US" sz="1280" spc="-1" strike="noStrike">
-              <a:latin typeface="Arial"/>
-            </a:endParaRPr>
-          </a:p>
-        </p:txBody>
-      </p:sp>
-      <p:sp>
-        <p:nvSpPr>
-          <p:cNvPr id="82" name="TextBox 7"/>
-          <p:cNvSpPr/>
-          <p:nvPr/>
-        </p:nvSpPr>
-        <p:spPr>
-          <a:xfrm>
-            <a:off x="4910400" y="1774080"/>
-            <a:ext cx="226800" cy="511560"/>
-          </a:xfrm>
-          <a:prstGeom prst="rect">
-            <a:avLst/>
-          </a:prstGeom>
-          <a:noFill/>
-          <a:ln w="0">
-            <a:noFill/>
-          </a:ln>
-        </p:spPr>
-        <p:style>
-          <a:lnRef idx="0"/>
-          <a:fillRef idx="0"/>
-          <a:effectRef idx="0"/>
-          <a:fontRef idx="minor"/>
-        </p:style>
-        <p:txBody>
-          <a:bodyPr lIns="73080" rIns="73080" tIns="73080" bIns="73080" anchor="t">
-            <a:spAutoFit/>
-          </a:bodyPr>
-          <a:p>
-            <a:pPr algn="ctr">
-              <a:lnSpc>
-                <a:spcPct val="100000"/>
-              </a:lnSpc>
-              <a:buNone/>
-            </a:pPr>
-            <a:r>
-              <a:rPr b="1" lang="en-US" sz="2400" spc="-1" strike="noStrike">
-                <a:solidFill>
-                  <a:srgbClr val="546478"/>
-                </a:solidFill>
-                <a:latin typeface="Arial"/>
-                <a:ea typeface="DejaVu Sans"/>
-              </a:rPr>
-              <a:t>&gt;</a:t>
-            </a:r>
-            <a:endParaRPr b="0" lang="en-US" sz="2400" spc="-1" strike="noStrike">
-              <a:latin typeface="Arial"/>
-            </a:endParaRPr>
-          </a:p>
-        </p:txBody>
-      </p:sp>
-      <p:sp>
-        <p:nvSpPr>
-          <p:cNvPr id="83" name="Rectangle 8"/>
-          <p:cNvSpPr/>
-          <p:nvPr/>
-        </p:nvSpPr>
-        <p:spPr>
-          <a:xfrm>
-            <a:off x="5166360" y="1225440"/>
-            <a:ext cx="2055600" cy="1443960"/>
-          </a:xfrm>
-          <a:prstGeom prst="rect">
-            <a:avLst/>
-          </a:prstGeom>
-          <a:solidFill>
-            <a:srgbClr val="fcf5dd"/>
-          </a:solidFill>
-          <a:ln w="17780">
-            <a:solidFill>
-              <a:srgbClr val="b88600"/>
-            </a:solidFill>
-            <a:round/>
-          </a:ln>
-          <a:effectLst>
-            <a:outerShdw blurRad="39960" dir="5400000" dist="23040" rotWithShape="0">
-              <a:srgbClr val="000000">
-                <a:alpha val="35000"/>
-              </a:srgbClr>
-            </a:outerShdw>
-          </a:effectLst>
-        </p:spPr>
-        <p:style>
-          <a:lnRef idx="1">
-            <a:schemeClr val="accent1"/>
-          </a:lnRef>
-          <a:fillRef idx="3">
-            <a:schemeClr val="accent1"/>
-          </a:fillRef>
-          <a:effectRef idx="2">
-            <a:schemeClr val="accent1"/>
-          </a:effectRef>
-          <a:fontRef idx="minor"/>
-        </p:style>
-        <p:txBody>
-          <a:bodyPr lIns="118800" rIns="118800" tIns="91440" bIns="91440" anchor="ctr">
-            <a:noAutofit/>
-          </a:bodyPr>
-          <a:p>
-            <a:pPr algn="ctr">
-              <a:lnSpc>
-                <a:spcPct val="100000"/>
-              </a:lnSpc>
-              <a:spcAft>
-                <a:spcPts val="201"/>
-              </a:spcAft>
-              <a:buNone/>
-            </a:pPr>
-            <a:r>
-              <a:rPr b="1" lang="en-US" sz="1280" spc="-1" strike="noStrike">
-                <a:solidFill>
-                  <a:srgbClr val="b88600"/>
-                </a:solidFill>
-                <a:latin typeface="Aptos"/>
-                <a:ea typeface="DejaVu Sans"/>
-              </a:rPr>
-              <a:t>Evidence router</a:t>
-            </a:r>
-            <a:endParaRPr b="0" lang="en-US" sz="1280" spc="-1" strike="noStrike">
-              <a:latin typeface="Arial"/>
-            </a:endParaRPr>
-          </a:p>
-          <a:p>
-            <a:pPr algn="ctr">
-              <a:lnSpc>
-                <a:spcPct val="100000"/>
-              </a:lnSpc>
-              <a:spcAft>
-                <a:spcPts val="201"/>
-              </a:spcAft>
-              <a:buNone/>
-            </a:pPr>
-            <a:r>
-              <a:rPr b="0" lang="en-US" sz="1280" spc="-1" strike="noStrike">
-                <a:solidFill>
-                  <a:srgbClr val="121b2b"/>
-                </a:solidFill>
-                <a:latin typeface="Aptos"/>
-                <a:ea typeface="DejaVu Sans"/>
-              </a:rPr>
-              <a:t>MLP+NMS selects compact,</a:t>
-            </a:r>
-            <a:endParaRPr b="0" lang="en-US" sz="1280" spc="-1" strike="noStrike">
-              <a:latin typeface="Arial"/>
-            </a:endParaRPr>
-          </a:p>
-          <a:p>
-            <a:pPr>
-              <a:lnSpc>
-                <a:spcPct val="100000"/>
-              </a:lnSpc>
-              <a:spcAft>
-                <a:spcPts val="201"/>
-              </a:spcAft>
-              <a:buNone/>
-            </a:pPr>
-            <a:r>
-              <a:rPr b="0" lang="en-US" sz="1280" spc="-1" strike="noStrike">
-                <a:solidFill>
-                  <a:srgbClr val="121b2b"/>
-                </a:solidFill>
-                <a:latin typeface="Aptos"/>
-                <a:ea typeface="DejaVu Sans"/>
-              </a:rPr>
-              <a:t>diverse evidence</a:t>
-            </a:r>
-            <a:endParaRPr b="0" lang="en-US" sz="1280" spc="-1" strike="noStrike">
-              <a:latin typeface="Arial"/>
-            </a:endParaRPr>
-          </a:p>
-        </p:txBody>
-      </p:sp>
-      <p:sp>
-        <p:nvSpPr>
-          <p:cNvPr id="84" name="TextBox 9"/>
-          <p:cNvSpPr/>
-          <p:nvPr/>
-        </p:nvSpPr>
-        <p:spPr>
-          <a:xfrm>
-            <a:off x="7242120" y="1774080"/>
-            <a:ext cx="226800" cy="511560"/>
-          </a:xfrm>
-          <a:prstGeom prst="rect">
-            <a:avLst/>
-          </a:prstGeom>
-          <a:noFill/>
-          <a:ln w="0">
-            <a:noFill/>
-          </a:ln>
-        </p:spPr>
-        <p:style>
-          <a:lnRef idx="0"/>
-          <a:fillRef idx="0"/>
-          <a:effectRef idx="0"/>
-          <a:fontRef idx="minor"/>
-        </p:style>
-        <p:txBody>
-          <a:bodyPr lIns="73080" rIns="73080" tIns="73080" bIns="73080" anchor="t">
-            <a:spAutoFit/>
-          </a:bodyPr>
-          <a:p>
-            <a:pPr algn="ctr">
-              <a:lnSpc>
-                <a:spcPct val="100000"/>
-              </a:lnSpc>
-              <a:buNone/>
-            </a:pPr>
-            <a:r>
-              <a:rPr b="1" lang="en-US" sz="2400" spc="-1" strike="noStrike">
-                <a:solidFill>
-                  <a:srgbClr val="546478"/>
-                </a:solidFill>
-                <a:latin typeface="Arial"/>
-                <a:ea typeface="DejaVu Sans"/>
-              </a:rPr>
-              <a:t>&gt;</a:t>
-            </a:r>
-            <a:endParaRPr b="0" lang="en-US" sz="2400" spc="-1" strike="noStrike">
-              <a:latin typeface="Arial"/>
-            </a:endParaRPr>
-          </a:p>
-        </p:txBody>
-      </p:sp>
-      <p:sp>
-        <p:nvSpPr>
-          <p:cNvPr id="85" name="Rectangle 10"/>
-          <p:cNvSpPr/>
-          <p:nvPr/>
-        </p:nvSpPr>
-        <p:spPr>
-          <a:xfrm>
-            <a:off x="7498080" y="1225440"/>
-            <a:ext cx="2055600" cy="1443960"/>
-          </a:xfrm>
-          <a:prstGeom prst="rect">
-            <a:avLst/>
-          </a:prstGeom>
-          <a:solidFill>
-            <a:srgbClr val="e2edf9"/>
-          </a:solidFill>
-          <a:ln w="17780">
-            <a:solidFill>
-              <a:srgbClr val="2b5b8b"/>
-            </a:solidFill>
-            <a:round/>
-          </a:ln>
-          <a:effectLst>
-            <a:outerShdw blurRad="39960" dir="5400000" dist="23040" rotWithShape="0">
-              <a:srgbClr val="000000">
-                <a:alpha val="35000"/>
-              </a:srgbClr>
-            </a:outerShdw>
-          </a:effectLst>
-        </p:spPr>
-        <p:style>
-          <a:lnRef idx="1">
-            <a:schemeClr val="accent1"/>
-          </a:lnRef>
-          <a:fillRef idx="3">
-            <a:schemeClr val="accent1"/>
-          </a:fillRef>
-          <a:effectRef idx="2">
-            <a:schemeClr val="accent1"/>
-          </a:effectRef>
-          <a:fontRef idx="minor"/>
-        </p:style>
-        <p:txBody>
-          <a:bodyPr lIns="118800" rIns="118800" tIns="91440" bIns="91440" anchor="ctr">
-            <a:noAutofit/>
-          </a:bodyPr>
-          <a:p>
-            <a:pPr algn="ctr">
-              <a:lnSpc>
-                <a:spcPct val="100000"/>
-              </a:lnSpc>
-              <a:spcAft>
-                <a:spcPts val="201"/>
-              </a:spcAft>
-              <a:buNone/>
-            </a:pPr>
-            <a:r>
-              <a:rPr b="1" lang="en-US" sz="1280" spc="-1" strike="noStrike">
-                <a:solidFill>
-                  <a:srgbClr val="2b5b8b"/>
-                </a:solidFill>
-                <a:latin typeface="Aptos"/>
-                <a:ea typeface="DejaVu Sans"/>
-              </a:rPr>
-              <a:t>Qwen answerer</a:t>
-            </a:r>
-            <a:endParaRPr b="0" lang="en-US" sz="1280" spc="-1" strike="noStrike">
-              <a:latin typeface="Arial"/>
-            </a:endParaRPr>
-          </a:p>
-          <a:p>
-            <a:pPr algn="ctr">
-              <a:lnSpc>
-                <a:spcPct val="100000"/>
-              </a:lnSpc>
-              <a:spcAft>
-                <a:spcPts val="201"/>
-              </a:spcAft>
-              <a:buNone/>
-            </a:pPr>
-            <a:r>
-              <a:rPr b="0" lang="en-US" sz="1280" spc="-1" strike="noStrike">
-                <a:solidFill>
-                  <a:srgbClr val="121b2b"/>
-                </a:solidFill>
-                <a:latin typeface="Aptos"/>
-                <a:ea typeface="DejaVu Sans"/>
-              </a:rPr>
-              <a:t>predicts answer using</a:t>
-            </a:r>
-            <a:endParaRPr b="0" lang="en-US" sz="1280" spc="-1" strike="noStrike">
-              <a:latin typeface="Arial"/>
-            </a:endParaRPr>
-          </a:p>
-          <a:p>
-            <a:pPr>
-              <a:lnSpc>
-                <a:spcPct val="100000"/>
-              </a:lnSpc>
-              <a:spcAft>
-                <a:spcPts val="201"/>
-              </a:spcAft>
-              <a:buNone/>
-            </a:pPr>
-            <a:r>
-              <a:rPr b="0" lang="en-US" sz="1280" spc="-1" strike="noStrike">
-                <a:solidFill>
-                  <a:srgbClr val="121b2b"/>
-                </a:solidFill>
-                <a:latin typeface="Aptos"/>
-                <a:ea typeface="DejaVu Sans"/>
-              </a:rPr>
-              <a:t>selected evidence only</a:t>
-            </a:r>
-            <a:endParaRPr b="0" lang="en-US" sz="1280" spc="-1" strike="noStrike">
-              <a:latin typeface="Arial"/>
-            </a:endParaRPr>
-          </a:p>
-        </p:txBody>
-      </p:sp>
-      <p:sp>
-        <p:nvSpPr>
-          <p:cNvPr id="86" name="TextBox 11"/>
-          <p:cNvSpPr/>
-          <p:nvPr/>
-        </p:nvSpPr>
-        <p:spPr>
-          <a:xfrm>
-            <a:off x="9573840" y="1774080"/>
-            <a:ext cx="226800" cy="511560"/>
-          </a:xfrm>
-          <a:prstGeom prst="rect">
-            <a:avLst/>
-          </a:prstGeom>
-          <a:noFill/>
-          <a:ln w="0">
-            <a:noFill/>
-          </a:ln>
-        </p:spPr>
-        <p:style>
-          <a:lnRef idx="0"/>
-          <a:fillRef idx="0"/>
-          <a:effectRef idx="0"/>
-          <a:fontRef idx="minor"/>
-        </p:style>
-        <p:txBody>
-          <a:bodyPr lIns="73080" rIns="73080" tIns="73080" bIns="73080" anchor="t">
-            <a:spAutoFit/>
-          </a:bodyPr>
-          <a:p>
-            <a:pPr algn="ctr">
-              <a:lnSpc>
-                <a:spcPct val="100000"/>
-              </a:lnSpc>
-              <a:buNone/>
-            </a:pPr>
-            <a:r>
-              <a:rPr b="1" lang="en-US" sz="2400" spc="-1" strike="noStrike">
-                <a:solidFill>
-                  <a:srgbClr val="546478"/>
-                </a:solidFill>
-                <a:latin typeface="Arial"/>
-                <a:ea typeface="DejaVu Sans"/>
-              </a:rPr>
-              <a:t>&gt;</a:t>
-            </a:r>
-            <a:endParaRPr b="0" lang="en-US" sz="2400" spc="-1" strike="noStrike">
-              <a:latin typeface="Arial"/>
-            </a:endParaRPr>
-          </a:p>
-        </p:txBody>
-      </p:sp>
-      <p:sp>
-        <p:nvSpPr>
-          <p:cNvPr id="87" name="Rectangle 12"/>
-          <p:cNvSpPr/>
-          <p:nvPr/>
-        </p:nvSpPr>
-        <p:spPr>
-          <a:xfrm>
-            <a:off x="9829800" y="1225440"/>
-            <a:ext cx="2055600" cy="1443960"/>
-          </a:xfrm>
-          <a:prstGeom prst="rect">
-            <a:avLst/>
-          </a:prstGeom>
-          <a:solidFill>
-            <a:srgbClr val="e0f1ec"/>
-          </a:solidFill>
-          <a:ln w="17780">
-            <a:solidFill>
-              <a:srgbClr val="37917e"/>
-            </a:solidFill>
-            <a:round/>
-          </a:ln>
-          <a:effectLst>
-            <a:outerShdw blurRad="39960" dir="5400000" dist="23040" rotWithShape="0">
-              <a:srgbClr val="000000">
-                <a:alpha val="35000"/>
-              </a:srgbClr>
-            </a:outerShdw>
-          </a:effectLst>
-        </p:spPr>
-        <p:style>
-          <a:lnRef idx="1">
-            <a:schemeClr val="accent1"/>
-          </a:lnRef>
-          <a:fillRef idx="3">
-            <a:schemeClr val="accent1"/>
-          </a:fillRef>
-          <a:effectRef idx="2">
-            <a:schemeClr val="accent1"/>
-          </a:effectRef>
-          <a:fontRef idx="minor"/>
-        </p:style>
-        <p:txBody>
-          <a:bodyPr lIns="118800" rIns="118800" tIns="91440" bIns="91440" anchor="ctr">
-            <a:noAutofit/>
-          </a:bodyPr>
-          <a:p>
-            <a:pPr algn="ctr">
-              <a:lnSpc>
-                <a:spcPct val="100000"/>
-              </a:lnSpc>
-              <a:spcAft>
-                <a:spcPts val="201"/>
-              </a:spcAft>
-              <a:buNone/>
-            </a:pPr>
-            <a:r>
-              <a:rPr b="1" lang="en-US" sz="1280" spc="-1" strike="noStrike">
-                <a:solidFill>
-                  <a:srgbClr val="37917e"/>
-                </a:solidFill>
-                <a:latin typeface="Aptos"/>
-                <a:ea typeface="DejaVu Sans"/>
-              </a:rPr>
-              <a:t>Evaluation</a:t>
-            </a:r>
-            <a:endParaRPr b="0" lang="en-US" sz="1280" spc="-1" strike="noStrike">
-              <a:latin typeface="Arial"/>
-            </a:endParaRPr>
-          </a:p>
-          <a:p>
-            <a:pPr algn="ctr">
-              <a:lnSpc>
-                <a:spcPct val="100000"/>
-              </a:lnSpc>
-              <a:spcAft>
-                <a:spcPts val="201"/>
-              </a:spcAft>
-              <a:buNone/>
-            </a:pPr>
-            <a:r>
-              <a:rPr b="0" lang="en-US" sz="1280" spc="-1" strike="noStrike">
-                <a:solidFill>
-                  <a:srgbClr val="121b2b"/>
-                </a:solidFill>
-                <a:latin typeface="Aptos"/>
-                <a:ea typeface="DejaVu Sans"/>
-              </a:rPr>
-              <a:t>Acc@QA + cost</a:t>
-            </a:r>
-            <a:endParaRPr b="0" lang="en-US" sz="1280" spc="-1" strike="noStrike">
-              <a:latin typeface="Arial"/>
-            </a:endParaRPr>
-          </a:p>
-          <a:p>
-            <a:pPr>
-              <a:lnSpc>
-                <a:spcPct val="100000"/>
-              </a:lnSpc>
-              <a:spcAft>
-                <a:spcPts val="201"/>
-              </a:spcAft>
-              <a:buNone/>
-            </a:pPr>
-            <a:r>
-              <a:rPr b="0" lang="en-US" sz="1280" spc="-1" strike="noStrike">
-                <a:solidFill>
-                  <a:srgbClr val="121b2b"/>
-                </a:solidFill>
-                <a:latin typeface="Aptos"/>
-                <a:ea typeface="DejaVu Sans"/>
-              </a:rPr>
-              <a:t>+ IoP/IoU + Acc@GQA</a:t>
-            </a:r>
-            <a:endParaRPr b="0" lang="en-US" sz="1280" spc="-1" strike="noStrike">
-              <a:latin typeface="Arial"/>
-            </a:endParaRPr>
-          </a:p>
-        </p:txBody>
-      </p:sp>
-      <p:sp>
-        <p:nvSpPr>
-          <p:cNvPr id="88" name="Rectangle 13"/>
-          <p:cNvSpPr/>
-          <p:nvPr/>
-        </p:nvSpPr>
-        <p:spPr>
-          <a:xfrm>
-            <a:off x="731520" y="3456360"/>
-            <a:ext cx="5164560" cy="1572120"/>
+            <a:ext cx="2055240" cy="1443600"/>
           </a:xfrm>
           <a:prstGeom prst="rect">
             <a:avLst/>
@@ -14947,30 +14307,6 @@
             <a:noAutofit/>
           </a:bodyPr>
           <a:p>
-            <a:pPr algn="ctr">
-              <a:lnSpc>
-                <a:spcPct val="100000"/>
-              </a:lnSpc>
-              <a:spcAft>
-                <a:spcPts val="201"/>
-              </a:spcAft>
-              <a:buNone/>
-            </a:pPr>
-            <a:r>
-              <a:rPr b="1" lang="en-US" sz="1380" spc="-1" strike="noStrike">
-                <a:solidFill>
-                  <a:srgbClr val="37917e"/>
-                </a:solidFill>
-                <a:latin typeface="Aptos"/>
-                <a:ea typeface="DejaVu Sans"/>
-              </a:rPr>
-              <a:t>Controlled answerer swap</a:t>
-            </a:r>
-            <a:endParaRPr b="0" lang="en-US" sz="1380" spc="-1" strike="noStrike">
-              <a:latin typeface="Arial"/>
-            </a:endParaRPr>
-          </a:p>
-          <a:p>
             <a:pPr>
               <a:lnSpc>
                 <a:spcPct val="100000"/>
@@ -14981,16 +14317,64 @@
               <a:buNone/>
             </a:pPr>
             <a:r>
-              <a:rPr b="0" lang="en-US" sz="1530" spc="-1" strike="noStrike">
+              <a:rPr b="1" lang="en-US" sz="1280" spc="-1" strike="noStrike">
+                <a:solidFill>
+                  <a:srgbClr val="37917e"/>
+                </a:solidFill>
+                <a:latin typeface="Aptos"/>
+                <a:ea typeface="DejaVu Sans"/>
+              </a:rPr>
+              <a:t>Candidate pool</a:t>
+            </a:r>
+            <a:endParaRPr b="0" lang="en-US" sz="1280" spc="-1" strike="noStrike">
+              <a:latin typeface="Arial"/>
+            </a:endParaRPr>
+          </a:p>
+          <a:p>
+            <a:pPr>
+              <a:lnSpc>
+                <a:spcPct val="100000"/>
+              </a:lnSpc>
+              <a:spcAft>
+                <a:spcPts val="201"/>
+              </a:spcAft>
+              <a:buNone/>
+            </a:pPr>
+            <a:r>
+              <a:rPr b="0" lang="en-US" sz="1280" spc="-1" strike="noStrike">
                 <a:solidFill>
                   <a:srgbClr val="121b2b"/>
                 </a:solidFill>
                 <a:latin typeface="Aptos"/>
                 <a:ea typeface="DejaVu Sans"/>
               </a:rPr>
-              <a:t>Keep selected evidence fixed, then swap only the answerer. This separates routing quality from visual reasoning quality.</a:t>
+              <a:t>keyframes + short</a:t>
             </a:r>
-            <a:endParaRPr b="0" lang="en-US" sz="1530" spc="-1" strike="noStrike">
+            <a:endParaRPr b="0" lang="en-US" sz="1280" spc="-1" strike="noStrike">
+              <a:latin typeface="Arial"/>
+            </a:endParaRPr>
+          </a:p>
+          <a:p>
+            <a:pPr>
+              <a:lnSpc>
+                <a:spcPct val="100000"/>
+              </a:lnSpc>
+              <a:spcAft>
+                <a:spcPts val="201"/>
+              </a:spcAft>
+              <a:buNone/>
+            </a:pPr>
+            <a:r>
+              <a:rPr b="0" lang="en-US" sz="1280" spc="-1" strike="noStrike">
+                <a:solidFill>
+                  <a:srgbClr val="121b2b"/>
+                </a:solidFill>
+                <a:latin typeface="Aptos"/>
+                <a:ea typeface="DejaVu Sans"/>
+              </a:rPr>
+              <a:t>temporal segments</a:t>
+            </a:r>
+            <a:endParaRPr b="0" lang="en-US" sz="1280" spc="-1" strike="noStrike">
               <a:latin typeface="Arial"/>
             </a:endParaRPr>
           </a:p>
@@ -14998,14 +14382,239 @@
       </p:sp>
       <p:sp>
         <p:nvSpPr>
-          <p:cNvPr id="89" name="Rectangle 14"/>
+          <p:cNvPr id="82" name="TextBox 7"/>
           <p:cNvSpPr/>
           <p:nvPr/>
         </p:nvSpPr>
         <p:spPr>
           <a:xfrm>
-            <a:off x="6263640" y="3456360"/>
-            <a:ext cx="5164560" cy="1572120"/>
+            <a:off x="4910400" y="1774080"/>
+            <a:ext cx="226440" cy="511560"/>
+          </a:xfrm>
+          <a:prstGeom prst="rect">
+            <a:avLst/>
+          </a:prstGeom>
+          <a:noFill/>
+          <a:ln w="0">
+            <a:noFill/>
+          </a:ln>
+        </p:spPr>
+        <p:style>
+          <a:lnRef idx="0"/>
+          <a:fillRef idx="0"/>
+          <a:effectRef idx="0"/>
+          <a:fontRef idx="minor"/>
+        </p:style>
+        <p:txBody>
+          <a:bodyPr lIns="73080" rIns="73080" tIns="73080" bIns="73080" anchor="t">
+            <a:spAutoFit/>
+          </a:bodyPr>
+          <a:p>
+            <a:pPr>
+              <a:lnSpc>
+                <a:spcPct val="100000"/>
+              </a:lnSpc>
+              <a:buNone/>
+            </a:pPr>
+            <a:r>
+              <a:rPr b="1" lang="en-US" sz="2400" spc="-1" strike="noStrike">
+                <a:solidFill>
+                  <a:srgbClr val="546478"/>
+                </a:solidFill>
+                <a:latin typeface="Arial"/>
+                <a:ea typeface="DejaVu Sans"/>
+              </a:rPr>
+              <a:t>&gt;</a:t>
+            </a:r>
+            <a:endParaRPr b="0" lang="en-US" sz="2400" spc="-1" strike="noStrike">
+              <a:latin typeface="Arial"/>
+            </a:endParaRPr>
+          </a:p>
+        </p:txBody>
+      </p:sp>
+      <p:sp>
+        <p:nvSpPr>
+          <p:cNvPr id="83" name="Rectangle 8"/>
+          <p:cNvSpPr/>
+          <p:nvPr/>
+        </p:nvSpPr>
+        <p:spPr>
+          <a:xfrm>
+            <a:off x="5166360" y="1225440"/>
+            <a:ext cx="2055240" cy="1443600"/>
+          </a:xfrm>
+          <a:prstGeom prst="rect">
+            <a:avLst/>
+          </a:prstGeom>
+          <a:solidFill>
+            <a:srgbClr val="fcf5dd"/>
+          </a:solidFill>
+          <a:ln w="17780">
+            <a:solidFill>
+              <a:srgbClr val="b88600"/>
+            </a:solidFill>
+            <a:round/>
+          </a:ln>
+          <a:effectLst>
+            <a:outerShdw blurRad="39960" dir="5400000" dist="23040" rotWithShape="0">
+              <a:srgbClr val="000000">
+                <a:alpha val="35000"/>
+              </a:srgbClr>
+            </a:outerShdw>
+          </a:effectLst>
+        </p:spPr>
+        <p:style>
+          <a:lnRef idx="1">
+            <a:schemeClr val="accent1"/>
+          </a:lnRef>
+          <a:fillRef idx="3">
+            <a:schemeClr val="accent1"/>
+          </a:fillRef>
+          <a:effectRef idx="2">
+            <a:schemeClr val="accent1"/>
+          </a:effectRef>
+          <a:fontRef idx="minor"/>
+        </p:style>
+        <p:txBody>
+          <a:bodyPr lIns="164520" rIns="164520" tIns="91440" bIns="91440" anchor="ctr">
+            <a:noAutofit/>
+          </a:bodyPr>
+          <a:p>
+            <a:pPr>
+              <a:lnSpc>
+                <a:spcPct val="100000"/>
+              </a:lnSpc>
+              <a:spcAft>
+                <a:spcPts val="201"/>
+              </a:spcAft>
+              <a:buNone/>
+            </a:pPr>
+            <a:r>
+              <a:rPr b="1" lang="en-US" sz="1280" spc="-1" strike="noStrike">
+                <a:solidFill>
+                  <a:srgbClr val="b88600"/>
+                </a:solidFill>
+                <a:latin typeface="Aptos"/>
+                <a:ea typeface="DejaVu Sans"/>
+              </a:rPr>
+              <a:t>Evidence router</a:t>
+            </a:r>
+            <a:endParaRPr b="0" lang="en-US" sz="1280" spc="-1" strike="noStrike">
+              <a:latin typeface="Arial"/>
+            </a:endParaRPr>
+          </a:p>
+          <a:p>
+            <a:pPr>
+              <a:lnSpc>
+                <a:spcPct val="100000"/>
+              </a:lnSpc>
+              <a:spcAft>
+                <a:spcPts val="201"/>
+              </a:spcAft>
+              <a:buNone/>
+            </a:pPr>
+            <a:r>
+              <a:rPr b="0" lang="en-US" sz="1280" spc="-1" strike="noStrike">
+                <a:solidFill>
+                  <a:srgbClr val="121b2b"/>
+                </a:solidFill>
+                <a:latin typeface="Aptos"/>
+                <a:ea typeface="DejaVu Sans"/>
+              </a:rPr>
+              <a:t>MLP+NMS selects compact,</a:t>
+            </a:r>
+            <a:endParaRPr b="0" lang="en-US" sz="1280" spc="-1" strike="noStrike">
+              <a:latin typeface="Arial"/>
+            </a:endParaRPr>
+          </a:p>
+          <a:p>
+            <a:pPr>
+              <a:lnSpc>
+                <a:spcPct val="100000"/>
+              </a:lnSpc>
+              <a:spcAft>
+                <a:spcPts val="201"/>
+              </a:spcAft>
+              <a:buNone/>
+            </a:pPr>
+            <a:r>
+              <a:rPr b="0" lang="en-US" sz="1280" spc="-1" strike="noStrike">
+                <a:solidFill>
+                  <a:srgbClr val="121b2b"/>
+                </a:solidFill>
+                <a:latin typeface="Aptos"/>
+                <a:ea typeface="DejaVu Sans"/>
+              </a:rPr>
+              <a:t>diverse evidence</a:t>
+            </a:r>
+            <a:endParaRPr b="0" lang="en-US" sz="1280" spc="-1" strike="noStrike">
+              <a:latin typeface="Arial"/>
+            </a:endParaRPr>
+          </a:p>
+        </p:txBody>
+      </p:sp>
+      <p:sp>
+        <p:nvSpPr>
+          <p:cNvPr id="84" name="TextBox 9"/>
+          <p:cNvSpPr/>
+          <p:nvPr/>
+        </p:nvSpPr>
+        <p:spPr>
+          <a:xfrm>
+            <a:off x="7242120" y="1774080"/>
+            <a:ext cx="226440" cy="511560"/>
+          </a:xfrm>
+          <a:prstGeom prst="rect">
+            <a:avLst/>
+          </a:prstGeom>
+          <a:noFill/>
+          <a:ln w="0">
+            <a:noFill/>
+          </a:ln>
+        </p:spPr>
+        <p:style>
+          <a:lnRef idx="0"/>
+          <a:fillRef idx="0"/>
+          <a:effectRef idx="0"/>
+          <a:fontRef idx="minor"/>
+        </p:style>
+        <p:txBody>
+          <a:bodyPr lIns="73080" rIns="73080" tIns="73080" bIns="73080" anchor="t">
+            <a:spAutoFit/>
+          </a:bodyPr>
+          <a:p>
+            <a:pPr>
+              <a:lnSpc>
+                <a:spcPct val="100000"/>
+              </a:lnSpc>
+              <a:buNone/>
+            </a:pPr>
+            <a:r>
+              <a:rPr b="1" lang="en-US" sz="2400" spc="-1" strike="noStrike">
+                <a:solidFill>
+                  <a:srgbClr val="546478"/>
+                </a:solidFill>
+                <a:latin typeface="Arial"/>
+                <a:ea typeface="DejaVu Sans"/>
+              </a:rPr>
+              <a:t>&gt;</a:t>
+            </a:r>
+            <a:endParaRPr b="0" lang="en-US" sz="2400" spc="-1" strike="noStrike">
+              <a:latin typeface="Arial"/>
+            </a:endParaRPr>
+          </a:p>
+        </p:txBody>
+      </p:sp>
+      <p:sp>
+        <p:nvSpPr>
+          <p:cNvPr id="85" name="Rectangle 10"/>
+          <p:cNvSpPr/>
+          <p:nvPr/>
+        </p:nvSpPr>
+        <p:spPr>
+          <a:xfrm>
+            <a:off x="7498080" y="1225440"/>
+            <a:ext cx="2055240" cy="1443600"/>
           </a:xfrm>
           <a:prstGeom prst="rect">
             <a:avLst/>
@@ -15044,7 +14653,398 @@
             <a:noAutofit/>
           </a:bodyPr>
           <a:p>
-            <a:pPr algn="ctr">
+            <a:pPr>
+              <a:lnSpc>
+                <a:spcPct val="100000"/>
+              </a:lnSpc>
+              <a:spcAft>
+                <a:spcPts val="201"/>
+              </a:spcAft>
+              <a:buNone/>
+            </a:pPr>
+            <a:r>
+              <a:rPr b="1" lang="en-US" sz="1280" spc="-1" strike="noStrike">
+                <a:solidFill>
+                  <a:srgbClr val="2b5b8b"/>
+                </a:solidFill>
+                <a:latin typeface="Aptos"/>
+                <a:ea typeface="DejaVu Sans"/>
+              </a:rPr>
+              <a:t>Qwen answerer</a:t>
+            </a:r>
+            <a:endParaRPr b="0" lang="en-US" sz="1280" spc="-1" strike="noStrike">
+              <a:latin typeface="Arial"/>
+            </a:endParaRPr>
+          </a:p>
+          <a:p>
+            <a:pPr>
+              <a:lnSpc>
+                <a:spcPct val="100000"/>
+              </a:lnSpc>
+              <a:spcAft>
+                <a:spcPts val="201"/>
+              </a:spcAft>
+              <a:buNone/>
+            </a:pPr>
+            <a:r>
+              <a:rPr b="0" lang="en-US" sz="1280" spc="-1" strike="noStrike">
+                <a:solidFill>
+                  <a:srgbClr val="121b2b"/>
+                </a:solidFill>
+                <a:latin typeface="Aptos"/>
+                <a:ea typeface="DejaVu Sans"/>
+              </a:rPr>
+              <a:t>predicts answer using</a:t>
+            </a:r>
+            <a:endParaRPr b="0" lang="en-US" sz="1280" spc="-1" strike="noStrike">
+              <a:latin typeface="Arial"/>
+            </a:endParaRPr>
+          </a:p>
+          <a:p>
+            <a:pPr>
+              <a:lnSpc>
+                <a:spcPct val="100000"/>
+              </a:lnSpc>
+              <a:spcAft>
+                <a:spcPts val="201"/>
+              </a:spcAft>
+              <a:buNone/>
+            </a:pPr>
+            <a:r>
+              <a:rPr b="0" lang="en-US" sz="1280" spc="-1" strike="noStrike">
+                <a:solidFill>
+                  <a:srgbClr val="121b2b"/>
+                </a:solidFill>
+                <a:latin typeface="Aptos"/>
+                <a:ea typeface="DejaVu Sans"/>
+              </a:rPr>
+              <a:t>selected evidence only</a:t>
+            </a:r>
+            <a:endParaRPr b="0" lang="en-US" sz="1280" spc="-1" strike="noStrike">
+              <a:latin typeface="Arial"/>
+            </a:endParaRPr>
+          </a:p>
+        </p:txBody>
+      </p:sp>
+      <p:sp>
+        <p:nvSpPr>
+          <p:cNvPr id="86" name="TextBox 11"/>
+          <p:cNvSpPr/>
+          <p:nvPr/>
+        </p:nvSpPr>
+        <p:spPr>
+          <a:xfrm>
+            <a:off x="9573840" y="1774080"/>
+            <a:ext cx="226440" cy="511560"/>
+          </a:xfrm>
+          <a:prstGeom prst="rect">
+            <a:avLst/>
+          </a:prstGeom>
+          <a:noFill/>
+          <a:ln w="0">
+            <a:noFill/>
+          </a:ln>
+        </p:spPr>
+        <p:style>
+          <a:lnRef idx="0"/>
+          <a:fillRef idx="0"/>
+          <a:effectRef idx="0"/>
+          <a:fontRef idx="minor"/>
+        </p:style>
+        <p:txBody>
+          <a:bodyPr lIns="73080" rIns="73080" tIns="73080" bIns="73080" anchor="t">
+            <a:spAutoFit/>
+          </a:bodyPr>
+          <a:p>
+            <a:pPr>
+              <a:lnSpc>
+                <a:spcPct val="100000"/>
+              </a:lnSpc>
+              <a:buNone/>
+            </a:pPr>
+            <a:r>
+              <a:rPr b="1" lang="en-US" sz="2400" spc="-1" strike="noStrike">
+                <a:solidFill>
+                  <a:srgbClr val="546478"/>
+                </a:solidFill>
+                <a:latin typeface="Arial"/>
+                <a:ea typeface="DejaVu Sans"/>
+              </a:rPr>
+              <a:t>&gt;</a:t>
+            </a:r>
+            <a:endParaRPr b="0" lang="en-US" sz="2400" spc="-1" strike="noStrike">
+              <a:latin typeface="Arial"/>
+            </a:endParaRPr>
+          </a:p>
+        </p:txBody>
+      </p:sp>
+      <p:sp>
+        <p:nvSpPr>
+          <p:cNvPr id="87" name="Rectangle 12"/>
+          <p:cNvSpPr/>
+          <p:nvPr/>
+        </p:nvSpPr>
+        <p:spPr>
+          <a:xfrm>
+            <a:off x="9829800" y="1225440"/>
+            <a:ext cx="2055240" cy="1443600"/>
+          </a:xfrm>
+          <a:prstGeom prst="rect">
+            <a:avLst/>
+          </a:prstGeom>
+          <a:solidFill>
+            <a:srgbClr val="e0f1ec"/>
+          </a:solidFill>
+          <a:ln w="17780">
+            <a:solidFill>
+              <a:srgbClr val="37917e"/>
+            </a:solidFill>
+            <a:round/>
+          </a:ln>
+          <a:effectLst>
+            <a:outerShdw blurRad="39960" dir="5400000" dist="23040" rotWithShape="0">
+              <a:srgbClr val="000000">
+                <a:alpha val="35000"/>
+              </a:srgbClr>
+            </a:outerShdw>
+          </a:effectLst>
+        </p:spPr>
+        <p:style>
+          <a:lnRef idx="1">
+            <a:schemeClr val="accent1"/>
+          </a:lnRef>
+          <a:fillRef idx="3">
+            <a:schemeClr val="accent1"/>
+          </a:fillRef>
+          <a:effectRef idx="2">
+            <a:schemeClr val="accent1"/>
+          </a:effectRef>
+          <a:fontRef idx="minor"/>
+        </p:style>
+        <p:txBody>
+          <a:bodyPr lIns="164520" rIns="164520" tIns="91440" bIns="91440" anchor="ctr">
+            <a:noAutofit/>
+          </a:bodyPr>
+          <a:p>
+            <a:pPr>
+              <a:lnSpc>
+                <a:spcPct val="100000"/>
+              </a:lnSpc>
+              <a:spcAft>
+                <a:spcPts val="201"/>
+              </a:spcAft>
+              <a:buNone/>
+            </a:pPr>
+            <a:r>
+              <a:rPr b="1" lang="en-US" sz="1280" spc="-1" strike="noStrike">
+                <a:solidFill>
+                  <a:srgbClr val="37917e"/>
+                </a:solidFill>
+                <a:latin typeface="Aptos"/>
+                <a:ea typeface="DejaVu Sans"/>
+              </a:rPr>
+              <a:t>Evaluation</a:t>
+            </a:r>
+            <a:endParaRPr b="0" lang="en-US" sz="1280" spc="-1" strike="noStrike">
+              <a:latin typeface="Arial"/>
+            </a:endParaRPr>
+          </a:p>
+          <a:p>
+            <a:pPr>
+              <a:lnSpc>
+                <a:spcPct val="100000"/>
+              </a:lnSpc>
+              <a:spcAft>
+                <a:spcPts val="201"/>
+              </a:spcAft>
+              <a:buNone/>
+            </a:pPr>
+            <a:r>
+              <a:rPr b="0" lang="en-US" sz="1280" spc="-1" strike="noStrike">
+                <a:solidFill>
+                  <a:srgbClr val="121b2b"/>
+                </a:solidFill>
+                <a:latin typeface="Aptos"/>
+                <a:ea typeface="DejaVu Sans"/>
+              </a:rPr>
+              <a:t>Acc@QA + cost</a:t>
+            </a:r>
+            <a:endParaRPr b="0" lang="en-US" sz="1280" spc="-1" strike="noStrike">
+              <a:latin typeface="Arial"/>
+            </a:endParaRPr>
+          </a:p>
+          <a:p>
+            <a:pPr>
+              <a:lnSpc>
+                <a:spcPct val="100000"/>
+              </a:lnSpc>
+              <a:spcAft>
+                <a:spcPts val="201"/>
+              </a:spcAft>
+              <a:buNone/>
+            </a:pPr>
+            <a:r>
+              <a:rPr b="0" lang="en-US" sz="1280" spc="-1" strike="noStrike">
+                <a:solidFill>
+                  <a:srgbClr val="121b2b"/>
+                </a:solidFill>
+                <a:latin typeface="Aptos"/>
+                <a:ea typeface="DejaVu Sans"/>
+              </a:rPr>
+              <a:t>+ IoP/IoU + Acc@GQA</a:t>
+            </a:r>
+            <a:endParaRPr b="0" lang="en-US" sz="1280" spc="-1" strike="noStrike">
+              <a:latin typeface="Arial"/>
+            </a:endParaRPr>
+          </a:p>
+        </p:txBody>
+      </p:sp>
+      <p:sp>
+        <p:nvSpPr>
+          <p:cNvPr id="88" name="Rectangle 13"/>
+          <p:cNvSpPr/>
+          <p:nvPr/>
+        </p:nvSpPr>
+        <p:spPr>
+          <a:xfrm>
+            <a:off x="731520" y="3456360"/>
+            <a:ext cx="5164200" cy="1571760"/>
+          </a:xfrm>
+          <a:prstGeom prst="rect">
+            <a:avLst/>
+          </a:prstGeom>
+          <a:solidFill>
+            <a:srgbClr val="e0f1ec"/>
+          </a:solidFill>
+          <a:ln w="17780">
+            <a:solidFill>
+              <a:srgbClr val="37917e"/>
+            </a:solidFill>
+            <a:round/>
+          </a:ln>
+          <a:effectLst>
+            <a:outerShdw blurRad="39960" dir="5400000" dist="23040" rotWithShape="0">
+              <a:srgbClr val="000000">
+                <a:alpha val="35000"/>
+              </a:srgbClr>
+            </a:outerShdw>
+          </a:effectLst>
+        </p:spPr>
+        <p:style>
+          <a:lnRef idx="1">
+            <a:schemeClr val="accent1"/>
+          </a:lnRef>
+          <a:fillRef idx="3">
+            <a:schemeClr val="accent1"/>
+          </a:fillRef>
+          <a:effectRef idx="2">
+            <a:schemeClr val="accent1"/>
+          </a:effectRef>
+          <a:fontRef idx="minor"/>
+        </p:style>
+        <p:txBody>
+          <a:bodyPr lIns="164520" rIns="164520" tIns="91440" bIns="91440" anchor="ctr">
+            <a:noAutofit/>
+          </a:bodyPr>
+          <a:p>
+            <a:pPr>
+              <a:lnSpc>
+                <a:spcPct val="100000"/>
+              </a:lnSpc>
+              <a:spcAft>
+                <a:spcPts val="201"/>
+              </a:spcAft>
+              <a:buNone/>
+            </a:pPr>
+            <a:r>
+              <a:rPr b="1" lang="en-US" sz="1380" spc="-1" strike="noStrike">
+                <a:solidFill>
+                  <a:srgbClr val="37917e"/>
+                </a:solidFill>
+                <a:latin typeface="Aptos"/>
+                <a:ea typeface="DejaVu Sans"/>
+              </a:rPr>
+              <a:t>Controlled answerer swap</a:t>
+            </a:r>
+            <a:endParaRPr b="0" lang="en-US" sz="1380" spc="-1" strike="noStrike">
+              <a:latin typeface="Arial"/>
+            </a:endParaRPr>
+          </a:p>
+          <a:p>
+            <a:pPr>
+              <a:lnSpc>
+                <a:spcPct val="100000"/>
+              </a:lnSpc>
+              <a:spcAft>
+                <a:spcPts val="201"/>
+              </a:spcAft>
+              <a:buNone/>
+            </a:pPr>
+            <a:r>
+              <a:rPr b="0" lang="en-US" sz="1530" spc="-1" strike="noStrike">
+                <a:solidFill>
+                  <a:srgbClr val="121b2b"/>
+                </a:solidFill>
+                <a:latin typeface="Aptos"/>
+                <a:ea typeface="DejaVu Sans"/>
+              </a:rPr>
+              <a:t>Keep selected evidence fixed, then swap only the answerer. This separates routing quality from visual reasoning quality.</a:t>
+            </a:r>
+            <a:endParaRPr b="0" lang="en-US" sz="1530" spc="-1" strike="noStrike">
+              <a:latin typeface="Arial"/>
+            </a:endParaRPr>
+          </a:p>
+        </p:txBody>
+      </p:sp>
+      <p:sp>
+        <p:nvSpPr>
+          <p:cNvPr id="89" name="Rectangle 14"/>
+          <p:cNvSpPr/>
+          <p:nvPr/>
+        </p:nvSpPr>
+        <p:spPr>
+          <a:xfrm>
+            <a:off x="6263640" y="3456360"/>
+            <a:ext cx="5164200" cy="1571760"/>
+          </a:xfrm>
+          <a:prstGeom prst="rect">
+            <a:avLst/>
+          </a:prstGeom>
+          <a:solidFill>
+            <a:srgbClr val="e2edf9"/>
+          </a:solidFill>
+          <a:ln w="17780">
+            <a:solidFill>
+              <a:srgbClr val="2b5b8b"/>
+            </a:solidFill>
+            <a:round/>
+          </a:ln>
+          <a:effectLst>
+            <a:outerShdw blurRad="39960" dir="5400000" dist="23040" rotWithShape="0">
+              <a:srgbClr val="000000">
+                <a:alpha val="35000"/>
+              </a:srgbClr>
+            </a:outerShdw>
+          </a:effectLst>
+        </p:spPr>
+        <p:style>
+          <a:lnRef idx="1">
+            <a:schemeClr val="accent1"/>
+          </a:lnRef>
+          <a:fillRef idx="3">
+            <a:schemeClr val="accent1"/>
+          </a:fillRef>
+          <a:effectRef idx="2">
+            <a:schemeClr val="accent1"/>
+          </a:effectRef>
+          <a:fontRef idx="minor"/>
+        </p:style>
+        <p:txBody>
+          <a:bodyPr lIns="164520" rIns="164520" tIns="91440" bIns="91440" anchor="ctr">
+            <a:noAutofit/>
+          </a:bodyPr>
+          <a:p>
+            <a:pPr>
               <a:lnSpc>
                 <a:spcPct val="100000"/>
               </a:lnSpc>
@@ -15102,7 +15102,7 @@
         <p:spPr>
           <a:xfrm>
             <a:off x="822960" y="5358240"/>
-            <a:ext cx="10422360" cy="380520"/>
+            <a:ext cx="10422000" cy="380520"/>
           </a:xfrm>
           <a:prstGeom prst="rect">
             <a:avLst/>
@@ -15123,7 +15123,7 @@
             <a:spAutoFit/>
           </a:bodyPr>
           <a:p>
-            <a:pPr algn="ctr">
+            <a:pPr>
               <a:lnSpc>
                 <a:spcPct val="100000"/>
               </a:lnSpc>
@@ -15187,7 +15187,7 @@
         <p:spPr>
           <a:xfrm>
             <a:off x="0" y="0"/>
-            <a:ext cx="12189960" cy="565200"/>
+            <a:ext cx="12189600" cy="564840"/>
           </a:xfrm>
           <a:prstGeom prst="rect">
             <a:avLst/>
@@ -15228,7 +15228,7 @@
         <p:spPr>
           <a:xfrm>
             <a:off x="347400" y="73080"/>
-            <a:ext cx="9873720" cy="480960"/>
+            <a:ext cx="9873360" cy="480960"/>
           </a:xfrm>
           <a:prstGeom prst="rect">
             <a:avLst/>
@@ -15280,7 +15280,7 @@
         <p:spPr>
           <a:xfrm>
             <a:off x="10652760" y="82440"/>
-            <a:ext cx="1095480" cy="420120"/>
+            <a:ext cx="1095120" cy="420120"/>
           </a:xfrm>
           <a:prstGeom prst="rect">
             <a:avLst/>
@@ -17453,7 +17453,7 @@
         <p:spPr>
           <a:xfrm>
             <a:off x="685800" y="5559480"/>
-            <a:ext cx="10788120" cy="380520"/>
+            <a:ext cx="10787760" cy="380520"/>
           </a:xfrm>
           <a:prstGeom prst="rect">
             <a:avLst/>
@@ -17474,7 +17474,7 @@
             <a:spAutoFit/>
           </a:bodyPr>
           <a:p>
-            <a:pPr algn="ctr">
+            <a:pPr>
               <a:lnSpc>
                 <a:spcPct val="100000"/>
               </a:lnSpc>
@@ -17538,7 +17538,7 @@
         <p:spPr>
           <a:xfrm>
             <a:off x="0" y="0"/>
-            <a:ext cx="12189960" cy="565200"/>
+            <a:ext cx="12189600" cy="564840"/>
           </a:xfrm>
           <a:prstGeom prst="rect">
             <a:avLst/>
@@ -17579,7 +17579,7 @@
         <p:spPr>
           <a:xfrm>
             <a:off x="347400" y="73080"/>
-            <a:ext cx="9873720" cy="480960"/>
+            <a:ext cx="9873360" cy="480960"/>
           </a:xfrm>
           <a:prstGeom prst="rect">
             <a:avLst/>
@@ -17631,7 +17631,7 @@
         <p:spPr>
           <a:xfrm>
             <a:off x="10652760" y="82440"/>
-            <a:ext cx="1095480" cy="420120"/>
+            <a:ext cx="1095120" cy="420120"/>
           </a:xfrm>
           <a:prstGeom prst="rect">
             <a:avLst/>
@@ -17683,7 +17683,7 @@
         <p:spPr>
           <a:xfrm>
             <a:off x="594360" y="914400"/>
-            <a:ext cx="3335760" cy="1352520"/>
+            <a:ext cx="3335400" cy="1352160"/>
           </a:xfrm>
           <a:prstGeom prst="rect">
             <a:avLst/>
@@ -17718,11 +17718,11 @@
           <a:fontRef idx="minor"/>
         </p:style>
         <p:txBody>
-          <a:bodyPr lIns="137160" rIns="137160" tIns="91440" bIns="91440" anchor="ctr">
+          <a:bodyPr lIns="164520" rIns="164520" tIns="91440" bIns="91440" anchor="ctr">
             <a:noAutofit/>
           </a:bodyPr>
           <a:p>
-            <a:pPr algn="ctr">
+            <a:pPr>
               <a:lnSpc>
                 <a:spcPct val="100000"/>
               </a:lnSpc>
@@ -17746,7 +17746,7 @@
             </a:endParaRPr>
           </a:p>
           <a:p>
-            <a:pPr algn="ctr">
+            <a:pPr>
               <a:lnSpc>
                 <a:spcPct val="100000"/>
               </a:lnSpc>
@@ -17770,7 +17770,7 @@
             </a:endParaRPr>
           </a:p>
           <a:p>
-            <a:pPr algn="ctr">
+            <a:pPr>
               <a:lnSpc>
                 <a:spcPct val="100000"/>
               </a:lnSpc>
@@ -17828,7 +17828,7 @@
         <p:spPr>
           <a:xfrm>
             <a:off x="4434840" y="914400"/>
-            <a:ext cx="3335760" cy="1352520"/>
+            <a:ext cx="3335400" cy="1352160"/>
           </a:xfrm>
           <a:prstGeom prst="rect">
             <a:avLst/>
@@ -17863,11 +17863,11 @@
           <a:fontRef idx="minor"/>
         </p:style>
         <p:txBody>
-          <a:bodyPr lIns="137160" rIns="137160" tIns="91440" bIns="91440" anchor="ctr">
+          <a:bodyPr lIns="164520" rIns="164520" tIns="91440" bIns="91440" anchor="ctr">
             <a:noAutofit/>
           </a:bodyPr>
           <a:p>
-            <a:pPr algn="ctr">
+            <a:pPr>
               <a:lnSpc>
                 <a:spcPct val="100000"/>
               </a:lnSpc>
@@ -17891,7 +17891,7 @@
             </a:endParaRPr>
           </a:p>
           <a:p>
-            <a:pPr algn="ctr">
+            <a:pPr>
               <a:lnSpc>
                 <a:spcPct val="100000"/>
               </a:lnSpc>
@@ -17949,7 +17949,7 @@
         <p:spPr>
           <a:xfrm>
             <a:off x="8275320" y="914400"/>
-            <a:ext cx="3335760" cy="1352520"/>
+            <a:ext cx="3335400" cy="1352160"/>
           </a:xfrm>
           <a:prstGeom prst="rect">
             <a:avLst/>
@@ -17984,11 +17984,11 @@
           <a:fontRef idx="minor"/>
         </p:style>
         <p:txBody>
-          <a:bodyPr lIns="137160" rIns="137160" tIns="91440" bIns="91440" anchor="ctr">
+          <a:bodyPr lIns="164520" rIns="164520" tIns="91440" bIns="91440" anchor="ctr">
             <a:noAutofit/>
           </a:bodyPr>
           <a:p>
-            <a:pPr algn="ctr">
+            <a:pPr>
               <a:lnSpc>
                 <a:spcPct val="100000"/>
               </a:lnSpc>
@@ -18012,7 +18012,7 @@
             </a:endParaRPr>
           </a:p>
           <a:p>
-            <a:pPr algn="ctr">
+            <a:pPr>
               <a:lnSpc>
                 <a:spcPct val="100000"/>
               </a:lnSpc>
@@ -18036,7 +18036,7 @@
             </a:endParaRPr>
           </a:p>
           <a:p>
-            <a:pPr algn="ctr">
+            <a:pPr>
               <a:lnSpc>
                 <a:spcPct val="100000"/>
               </a:lnSpc>
@@ -18752,7 +18752,7 @@
         <p:spPr>
           <a:xfrm>
             <a:off x="914400" y="5413320"/>
-            <a:ext cx="10330920" cy="578520"/>
+            <a:ext cx="10330560" cy="578520"/>
           </a:xfrm>
           <a:prstGeom prst="rect">
             <a:avLst/>
@@ -18769,11 +18769,11 @@
           <a:fontRef idx="minor"/>
         </p:style>
         <p:txBody>
-          <a:bodyPr lIns="182880" rIns="182880" tIns="91440" bIns="91440" anchor="t">
+          <a:bodyPr lIns="164520" rIns="164520" tIns="91440" bIns="91440" anchor="t">
             <a:spAutoFit/>
           </a:bodyPr>
           <a:p>
-            <a:pPr algn="ctr">
+            <a:pPr>
               <a:lnSpc>
                 <a:spcPct val="100000"/>
               </a:lnSpc>
@@ -18837,7 +18837,7 @@
         <p:spPr>
           <a:xfrm>
             <a:off x="0" y="0"/>
-            <a:ext cx="12189960" cy="565200"/>
+            <a:ext cx="12189600" cy="564840"/>
           </a:xfrm>
           <a:prstGeom prst="rect">
             <a:avLst/>
@@ -18878,7 +18878,7 @@
         <p:spPr>
           <a:xfrm>
             <a:off x="347400" y="73080"/>
-            <a:ext cx="9873720" cy="480960"/>
+            <a:ext cx="9873360" cy="480960"/>
           </a:xfrm>
           <a:prstGeom prst="rect">
             <a:avLst/>
@@ -18930,7 +18930,7 @@
         <p:spPr>
           <a:xfrm>
             <a:off x="10652760" y="82440"/>
-            <a:ext cx="1095480" cy="420120"/>
+            <a:ext cx="1095120" cy="420120"/>
           </a:xfrm>
           <a:prstGeom prst="rect">
             <a:avLst/>
@@ -18986,7 +18986,7 @@
         <p:spPr>
           <a:xfrm>
             <a:off x="594360" y="822960"/>
-            <a:ext cx="11016720" cy="3884400"/>
+            <a:ext cx="11016360" cy="3884040"/>
           </a:xfrm>
           <a:prstGeom prst="rect">
             <a:avLst/>
@@ -19005,7 +19005,7 @@
         <p:spPr>
           <a:xfrm>
             <a:off x="594360" y="4617720"/>
-            <a:ext cx="3473280" cy="1535400"/>
+            <a:ext cx="3472920" cy="1535040"/>
           </a:xfrm>
           <a:prstGeom prst="rect">
             <a:avLst/>
@@ -19048,7 +19048,7 @@
         <p:spPr>
           <a:xfrm>
             <a:off x="704160" y="4754880"/>
-            <a:ext cx="3253680" cy="249480"/>
+            <a:ext cx="3253320" cy="249480"/>
           </a:xfrm>
           <a:prstGeom prst="rect">
             <a:avLst/>
@@ -19069,7 +19069,7 @@
             <a:spAutoFit/>
           </a:bodyPr>
           <a:p>
-            <a:pPr algn="ctr">
+            <a:pPr>
               <a:lnSpc>
                 <a:spcPct val="100000"/>
               </a:lnSpc>
@@ -19100,7 +19100,7 @@
         <p:spPr>
           <a:xfrm>
             <a:off x="758880" y="5139000"/>
-            <a:ext cx="3144240" cy="676800"/>
+            <a:ext cx="3143880" cy="786240"/>
           </a:xfrm>
           <a:prstGeom prst="rect">
             <a:avLst/>
@@ -19117,7 +19117,7 @@
           <a:fontRef idx="minor"/>
         </p:style>
         <p:txBody>
-          <a:bodyPr lIns="73080" rIns="73080" tIns="36720" bIns="36720" anchor="t">
+          <a:bodyPr lIns="164520" rIns="164520" tIns="91440" bIns="91440" anchor="t">
             <a:spAutoFit/>
           </a:bodyPr>
           <a:p>
@@ -19155,7 +19155,7 @@
         <p:spPr>
           <a:xfrm>
             <a:off x="4343400" y="4617720"/>
-            <a:ext cx="3473280" cy="1535400"/>
+            <a:ext cx="3472920" cy="1535040"/>
           </a:xfrm>
           <a:prstGeom prst="rect">
             <a:avLst/>
@@ -19198,7 +19198,7 @@
         <p:spPr>
           <a:xfrm>
             <a:off x="4453200" y="4754880"/>
-            <a:ext cx="3253680" cy="249480"/>
+            <a:ext cx="3253320" cy="249480"/>
           </a:xfrm>
           <a:prstGeom prst="rect">
             <a:avLst/>
@@ -19219,7 +19219,7 @@
             <a:spAutoFit/>
           </a:bodyPr>
           <a:p>
-            <a:pPr algn="ctr">
+            <a:pPr>
               <a:lnSpc>
                 <a:spcPct val="100000"/>
               </a:lnSpc>
@@ -19250,7 +19250,7 @@
         <p:spPr>
           <a:xfrm>
             <a:off x="4507920" y="5139000"/>
-            <a:ext cx="3144240" cy="475560"/>
+            <a:ext cx="3143880" cy="585000"/>
           </a:xfrm>
           <a:prstGeom prst="rect">
             <a:avLst/>
@@ -19267,7 +19267,7 @@
           <a:fontRef idx="minor"/>
         </p:style>
         <p:txBody>
-          <a:bodyPr lIns="73080" rIns="73080" tIns="36720" bIns="36720" anchor="t">
+          <a:bodyPr lIns="164520" rIns="164520" tIns="91440" bIns="91440" anchor="t">
             <a:spAutoFit/>
           </a:bodyPr>
           <a:p>
@@ -19305,7 +19305,7 @@
         <p:spPr>
           <a:xfrm>
             <a:off x="8092440" y="4617720"/>
-            <a:ext cx="3473280" cy="1535400"/>
+            <a:ext cx="3472920" cy="1535040"/>
           </a:xfrm>
           <a:prstGeom prst="rect">
             <a:avLst/>
@@ -19348,7 +19348,7 @@
         <p:spPr>
           <a:xfrm>
             <a:off x="8202240" y="4754880"/>
-            <a:ext cx="3253680" cy="249480"/>
+            <a:ext cx="3253320" cy="249480"/>
           </a:xfrm>
           <a:prstGeom prst="rect">
             <a:avLst/>
@@ -19369,7 +19369,7 @@
             <a:spAutoFit/>
           </a:bodyPr>
           <a:p>
-            <a:pPr algn="ctr">
+            <a:pPr>
               <a:lnSpc>
                 <a:spcPct val="100000"/>
               </a:lnSpc>
@@ -19400,7 +19400,7 @@
         <p:spPr>
           <a:xfrm>
             <a:off x="8256960" y="5139000"/>
-            <a:ext cx="3144240" cy="475560"/>
+            <a:ext cx="3143880" cy="585000"/>
           </a:xfrm>
           <a:prstGeom prst="rect">
             <a:avLst/>
@@ -19417,7 +19417,7 @@
           <a:fontRef idx="minor"/>
         </p:style>
         <p:txBody>
-          <a:bodyPr lIns="73080" rIns="73080" tIns="36720" bIns="36720" anchor="t">
+          <a:bodyPr lIns="164520" rIns="164520" tIns="91440" bIns="91440" anchor="t">
             <a:spAutoFit/>
           </a:bodyPr>
           <a:p>

</xml_diff>